<commit_message>
Formación Ajedrez: cada sesión de 5 horas con contenido, ejemplos, presentación y práctica (#659)
Cada una de las 8 sesiones dura 5 horas (40 en total: 7 virtuales y la presencial de 8:00 a. m. a 1:00 p. m.), con objetivos, cronograma de 300 minutos, temas con su artículo del Handbook de la FIDE, casos para comentar, ejercicios con respuesta (posiciones verificadas con chess.js), quiz y tarea. El generador lo vuelca en el fragmento protegido, las presentaciones, el cuadernillo de repaso y el PDF de ejercicios. Nuevo verificar-formacion.js.

Co-Authored-By: Claude Opus 5.5 <noreply@anthropic.com>
Claude-Session: https://claude.ai/code/session_0127yiL7aMDyRSuxN9ZRYVvP
</commit_message>
<xml_diff>
--- a/cursos/recursos/formacion-ajedrez/07-talleres-y-simulacros-de-arbitraje.pptx
+++ b/cursos/recursos/formacion-ajedrez/07-talleres-y-simulacros-de-arbitraje.pptx
@@ -10,6 +10,20 @@
     <p:sldId id="258" r:id="rId9"/>
     <p:sldId id="259" r:id="rId10"/>
     <p:sldId id="260" r:id="rId11"/>
+    <p:sldId id="261" r:id="rId12"/>
+    <p:sldId id="262" r:id="rId13"/>
+    <p:sldId id="263" r:id="rId14"/>
+    <p:sldId id="264" r:id="rId15"/>
+    <p:sldId id="265" r:id="rId16"/>
+    <p:sldId id="266" r:id="rId17"/>
+    <p:sldId id="267" r:id="rId18"/>
+    <p:sldId id="268" r:id="rId19"/>
+    <p:sldId id="269" r:id="rId20"/>
+    <p:sldId id="270" r:id="rId21"/>
+    <p:sldId id="271" r:id="rId22"/>
+    <p:sldId id="272" r:id="rId23"/>
+    <p:sldId id="273" r:id="rId24"/>
+    <p:sldId id="274" r:id="rId25"/>
   </p:sldIdLst>
   <p:sldSz cx="12191695" cy="6858000" type="screen4x3"/>
   <p:notesSz cx="6858000" cy="9144000"/>
@@ -3481,6 +3495,2254 @@
 </p:sld>
 </file>
 
+<file path=ppt/slides/slide10.xml><?xml version="1.0" encoding="utf-8"?>
+<p:sld xmlns:a="http://schemas.openxmlformats.org/drawingml/2006/main" xmlns:p="http://schemas.openxmlformats.org/presentationml/2006/main" xmlns:r="http://schemas.openxmlformats.org/officeDocument/2006/relationships">
+  <p:cSld>
+    <p:spTree>
+      <p:nvGrpSpPr>
+        <p:cNvPr id="1" name=""/>
+        <p:cNvGrpSpPr/>
+        <p:nvPr/>
+      </p:nvGrpSpPr>
+      <p:grpSpPr/>
+      <p:sp>
+        <p:nvSpPr>
+          <p:cNvPr id="2" name="Rectangle 1"/>
+          <p:cNvSpPr/>
+          <p:nvPr/>
+        </p:nvSpPr>
+        <p:spPr>
+          <a:xfrm>
+            <a:off x="0" y="0"/>
+            <a:ext cx="12191695" cy="6858000"/>
+          </a:xfrm>
+          <a:prstGeom prst="rect">
+            <a:avLst/>
+          </a:prstGeom>
+          <a:solidFill>
+            <a:srgbClr val="102A43"/>
+          </a:solidFill>
+          <a:ln>
+            <a:noFill/>
+          </a:ln>
+          <a:effectLst/>
+        </p:spPr>
+        <p:style>
+          <a:lnRef idx="1">
+            <a:schemeClr val="accent1"/>
+          </a:lnRef>
+          <a:fillRef idx="3">
+            <a:schemeClr val="accent1"/>
+          </a:fillRef>
+          <a:effectRef idx="2">
+            <a:schemeClr val="accent1"/>
+          </a:effectRef>
+          <a:fontRef idx="minor">
+            <a:schemeClr val="lt1"/>
+          </a:fontRef>
+        </p:style>
+        <p:txBody>
+          <a:bodyPr rtlCol="0" anchor="ctr"/>
+          <a:lstStyle/>
+          <a:p>
+            <a:pPr algn="ctr"/>
+          </a:p>
+        </p:txBody>
+      </p:sp>
+      <p:sp>
+        <p:nvSpPr>
+          <p:cNvPr id="3" name="TextBox 2"/>
+          <p:cNvSpPr txBox="1"/>
+          <p:nvPr/>
+        </p:nvSpPr>
+        <p:spPr>
+          <a:xfrm>
+            <a:off x="548640" y="548640"/>
+            <a:ext cx="11064240" cy="457200"/>
+          </a:xfrm>
+          <a:prstGeom prst="rect">
+            <a:avLst/>
+          </a:prstGeom>
+          <a:noFill/>
+        </p:spPr>
+        <p:txBody>
+          <a:bodyPr wrap="square">
+            <a:spAutoFit/>
+          </a:bodyPr>
+          <a:lstStyle/>
+          <a:p>
+            <a:r>
+              <a:rPr sz="1400" b="1">
+                <a:solidFill>
+                  <a:srgbClr val="F0B429"/>
+                </a:solidFill>
+                <a:latin typeface="Calibri"/>
+              </a:rPr>
+              <a:t>CASO 2 · DECISIÓN</a:t>
+            </a:r>
+          </a:p>
+        </p:txBody>
+      </p:sp>
+      <p:sp>
+        <p:nvSpPr>
+          <p:cNvPr id="4" name="TextBox 3"/>
+          <p:cNvSpPr txBox="1"/>
+          <p:nvPr/>
+        </p:nvSpPr>
+        <p:spPr>
+          <a:xfrm>
+            <a:off x="548640" y="1051560"/>
+            <a:ext cx="11064240" cy="822960"/>
+          </a:xfrm>
+          <a:prstGeom prst="rect">
+            <a:avLst/>
+          </a:prstGeom>
+          <a:noFill/>
+        </p:spPr>
+        <p:txBody>
+          <a:bodyPr wrap="square">
+            <a:spAutoFit/>
+          </a:bodyPr>
+          <a:lstStyle/>
+          <a:p>
+            <a:r>
+              <a:rPr sz="2600" b="1">
+                <a:solidFill>
+                  <a:srgbClr val="FFFFFF"/>
+                </a:solidFill>
+                <a:latin typeface="Cambria"/>
+              </a:rPr>
+              <a:t>Guion B: reclamo de triple repetición</a:t>
+            </a:r>
+          </a:p>
+        </p:txBody>
+      </p:sp>
+      <p:sp>
+        <p:nvSpPr>
+          <p:cNvPr id="5" name="TextBox 4"/>
+          <p:cNvSpPr txBox="1"/>
+          <p:nvPr/>
+        </p:nvSpPr>
+        <p:spPr>
+          <a:xfrm>
+            <a:off x="548640" y="2103120"/>
+            <a:ext cx="11064240" cy="3931920"/>
+          </a:xfrm>
+          <a:prstGeom prst="rect">
+            <a:avLst/>
+          </a:prstGeom>
+          <a:noFill/>
+        </p:spPr>
+        <p:txBody>
+          <a:bodyPr wrap="square">
+            <a:spAutoFit/>
+          </a:bodyPr>
+          <a:lstStyle/>
+          <a:p>
+            <a:r>
+              <a:rPr sz="2000" b="0">
+                <a:solidFill>
+                  <a:srgbClr val="CADCFC"/>
+                </a:solidFill>
+                <a:latin typeface="Calibri"/>
+              </a:rPr>
+              <a:t>Correcto si anotó la jugada sin hacerla y llamó al árbitro sin tocar ninguna pieza. Se verifica con las planillas; si el reclamo es correcto, son tablas de inmediato. Si no lo es, el reclamo cuenta como oferta de tablas y, en ritmo clásico, el rival recibe dos minutos.</a:t>
+            </a:r>
+          </a:p>
+        </p:txBody>
+      </p:sp>
+      <p:sp>
+        <p:nvSpPr>
+          <p:cNvPr id="6" name="TextBox 5"/>
+          <p:cNvSpPr txBox="1"/>
+          <p:nvPr/>
+        </p:nvSpPr>
+        <p:spPr>
+          <a:xfrm>
+            <a:off x="548640" y="6263640"/>
+            <a:ext cx="11064240" cy="365760"/>
+          </a:xfrm>
+          <a:prstGeom prst="rect">
+            <a:avLst/>
+          </a:prstGeom>
+          <a:noFill/>
+        </p:spPr>
+        <p:txBody>
+          <a:bodyPr wrap="square">
+            <a:spAutoFit/>
+          </a:bodyPr>
+          <a:lstStyle/>
+          <a:p>
+            <a:r>
+              <a:rPr sz="1100" b="0">
+                <a:solidFill>
+                  <a:srgbClr val="9FB3C8"/>
+                </a:solidFill>
+                <a:latin typeface="Calibri"/>
+              </a:rPr>
+              <a:t>Fuente: Leyes del Ajedrez 2023 (Handbook E.I.01), art. 9.1, 9.2, 9.4 y 9.5</a:t>
+            </a:r>
+          </a:p>
+        </p:txBody>
+      </p:sp>
+    </p:spTree>
+  </p:cSld>
+  <p:clrMapOvr>
+    <a:masterClrMapping/>
+  </p:clrMapOvr>
+</p:sld>
+</file>
+
+<file path=ppt/slides/slide11.xml><?xml version="1.0" encoding="utf-8"?>
+<p:sld xmlns:a="http://schemas.openxmlformats.org/drawingml/2006/main" xmlns:p="http://schemas.openxmlformats.org/presentationml/2006/main" xmlns:r="http://schemas.openxmlformats.org/officeDocument/2006/relationships">
+  <p:cSld>
+    <p:spTree>
+      <p:nvGrpSpPr>
+        <p:cNvPr id="1" name=""/>
+        <p:cNvGrpSpPr/>
+        <p:nvPr/>
+      </p:nvGrpSpPr>
+      <p:grpSpPr/>
+      <p:sp>
+        <p:nvSpPr>
+          <p:cNvPr id="2" name="Oval 1"/>
+          <p:cNvSpPr/>
+          <p:nvPr/>
+        </p:nvSpPr>
+        <p:spPr>
+          <a:xfrm>
+            <a:off x="548640" y="502920"/>
+            <a:ext cx="502920" cy="502920"/>
+          </a:xfrm>
+          <a:prstGeom prst="ellipse">
+            <a:avLst/>
+          </a:prstGeom>
+          <a:solidFill>
+            <a:srgbClr val="DE911D"/>
+          </a:solidFill>
+          <a:ln>
+            <a:noFill/>
+          </a:ln>
+          <a:effectLst/>
+        </p:spPr>
+        <p:style>
+          <a:lnRef idx="1">
+            <a:schemeClr val="accent1"/>
+          </a:lnRef>
+          <a:fillRef idx="3">
+            <a:schemeClr val="accent1"/>
+          </a:fillRef>
+          <a:effectRef idx="2">
+            <a:schemeClr val="accent1"/>
+          </a:effectRef>
+          <a:fontRef idx="minor">
+            <a:schemeClr val="lt1"/>
+          </a:fontRef>
+        </p:style>
+        <p:txBody>
+          <a:bodyPr rtlCol="0" anchor="ctr"/>
+          <a:lstStyle/>
+          <a:p>
+            <a:pPr algn="ctr"/>
+          </a:p>
+        </p:txBody>
+      </p:sp>
+      <p:sp>
+        <p:nvSpPr>
+          <p:cNvPr id="3" name="TextBox 2"/>
+          <p:cNvSpPr txBox="1"/>
+          <p:nvPr/>
+        </p:nvSpPr>
+        <p:spPr>
+          <a:xfrm>
+            <a:off x="548640" y="502920"/>
+            <a:ext cx="502920" cy="502920"/>
+          </a:xfrm>
+          <a:prstGeom prst="rect">
+            <a:avLst/>
+          </a:prstGeom>
+          <a:noFill/>
+        </p:spPr>
+        <p:txBody>
+          <a:bodyPr wrap="square">
+            <a:spAutoFit/>
+          </a:bodyPr>
+          <a:lstStyle/>
+          <a:p>
+            <a:pPr algn="ctr"/>
+            <a:r>
+              <a:rPr sz="2000" b="0">
+                <a:solidFill>
+                  <a:srgbClr val="0A1F33"/>
+                </a:solidFill>
+                <a:latin typeface="Calibri"/>
+              </a:rPr>
+              <a:t>?</a:t>
+            </a:r>
+          </a:p>
+        </p:txBody>
+      </p:sp>
+      <p:sp>
+        <p:nvSpPr>
+          <p:cNvPr id="4" name="TextBox 3"/>
+          <p:cNvSpPr txBox="1"/>
+          <p:nvPr/>
+        </p:nvSpPr>
+        <p:spPr>
+          <a:xfrm>
+            <a:off x="1234440" y="530352"/>
+            <a:ext cx="9144000" cy="457200"/>
+          </a:xfrm>
+          <a:prstGeom prst="rect">
+            <a:avLst/>
+          </a:prstGeom>
+          <a:noFill/>
+        </p:spPr>
+        <p:txBody>
+          <a:bodyPr wrap="square">
+            <a:spAutoFit/>
+          </a:bodyPr>
+          <a:lstStyle/>
+          <a:p>
+            <a:r>
+              <a:rPr sz="1400" b="1">
+                <a:solidFill>
+                  <a:srgbClr val="DE911D"/>
+                </a:solidFill>
+                <a:latin typeface="Calibri"/>
+              </a:rPr>
+              <a:t>CASO 3 · ¿QUÉ DECIDE LA PERSONA ÁRBITRA?</a:t>
+            </a:r>
+          </a:p>
+        </p:txBody>
+      </p:sp>
+      <p:sp>
+        <p:nvSpPr>
+          <p:cNvPr id="5" name="TextBox 4"/>
+          <p:cNvSpPr txBox="1"/>
+          <p:nvPr/>
+        </p:nvSpPr>
+        <p:spPr>
+          <a:xfrm>
+            <a:off x="548640" y="1051560"/>
+            <a:ext cx="11064240" cy="822960"/>
+          </a:xfrm>
+          <a:prstGeom prst="rect">
+            <a:avLst/>
+          </a:prstGeom>
+          <a:noFill/>
+        </p:spPr>
+        <p:txBody>
+          <a:bodyPr wrap="square">
+            <a:spAutoFit/>
+          </a:bodyPr>
+          <a:lstStyle/>
+          <a:p>
+            <a:r>
+              <a:rPr sz="2600" b="1">
+                <a:solidFill>
+                  <a:srgbClr val="0A1F33"/>
+                </a:solidFill>
+                <a:latin typeface="Cambria"/>
+              </a:rPr>
+              <a:t>Guion C: la oferta de tablas en el turno del rival</a:t>
+            </a:r>
+          </a:p>
+        </p:txBody>
+      </p:sp>
+      <p:sp>
+        <p:nvSpPr>
+          <p:cNvPr id="6" name="Rectangle 5"/>
+          <p:cNvSpPr/>
+          <p:nvPr/>
+        </p:nvSpPr>
+        <p:spPr>
+          <a:xfrm>
+            <a:off x="548640" y="1965960"/>
+            <a:ext cx="11064240" cy="4206240"/>
+          </a:xfrm>
+          <a:prstGeom prst="rect">
+            <a:avLst/>
+          </a:prstGeom>
+          <a:solidFill>
+            <a:srgbClr val="F0F4F8"/>
+          </a:solidFill>
+          <a:ln>
+            <a:noFill/>
+          </a:ln>
+          <a:effectLst/>
+        </p:spPr>
+        <p:style>
+          <a:lnRef idx="1">
+            <a:schemeClr val="accent1"/>
+          </a:lnRef>
+          <a:fillRef idx="3">
+            <a:schemeClr val="accent1"/>
+          </a:fillRef>
+          <a:effectRef idx="2">
+            <a:schemeClr val="accent1"/>
+          </a:effectRef>
+          <a:fontRef idx="minor">
+            <a:schemeClr val="lt1"/>
+          </a:fontRef>
+        </p:style>
+        <p:txBody>
+          <a:bodyPr rtlCol="0" anchor="ctr"/>
+          <a:lstStyle/>
+          <a:p>
+            <a:pPr algn="ctr"/>
+          </a:p>
+        </p:txBody>
+      </p:sp>
+      <p:sp>
+        <p:nvSpPr>
+          <p:cNvPr id="7" name="TextBox 6"/>
+          <p:cNvSpPr txBox="1"/>
+          <p:nvPr/>
+        </p:nvSpPr>
+        <p:spPr>
+          <a:xfrm>
+            <a:off x="914400" y="2240280"/>
+            <a:ext cx="10332720" cy="3749039"/>
+          </a:xfrm>
+          <a:prstGeom prst="rect">
+            <a:avLst/>
+          </a:prstGeom>
+          <a:noFill/>
+        </p:spPr>
+        <p:txBody>
+          <a:bodyPr wrap="square">
+            <a:spAutoFit/>
+          </a:bodyPr>
+          <a:lstStyle/>
+          <a:p>
+            <a:r>
+              <a:rPr sz="2000" b="0">
+                <a:solidFill>
+                  <a:srgbClr val="334E68"/>
+                </a:solidFill>
+                <a:latin typeface="Calibri"/>
+              </a:rPr>
+              <a:t>Un jugador ofrece tablas mientras corre el reloj de su rival.</a:t>
+            </a:r>
+          </a:p>
+        </p:txBody>
+      </p:sp>
+    </p:spTree>
+  </p:cSld>
+  <p:clrMapOvr>
+    <a:masterClrMapping/>
+  </p:clrMapOvr>
+</p:sld>
+</file>
+
+<file path=ppt/slides/slide12.xml><?xml version="1.0" encoding="utf-8"?>
+<p:sld xmlns:a="http://schemas.openxmlformats.org/drawingml/2006/main" xmlns:p="http://schemas.openxmlformats.org/presentationml/2006/main" xmlns:r="http://schemas.openxmlformats.org/officeDocument/2006/relationships">
+  <p:cSld>
+    <p:spTree>
+      <p:nvGrpSpPr>
+        <p:cNvPr id="1" name=""/>
+        <p:cNvGrpSpPr/>
+        <p:nvPr/>
+      </p:nvGrpSpPr>
+      <p:grpSpPr/>
+      <p:sp>
+        <p:nvSpPr>
+          <p:cNvPr id="2" name="Rectangle 1"/>
+          <p:cNvSpPr/>
+          <p:nvPr/>
+        </p:nvSpPr>
+        <p:spPr>
+          <a:xfrm>
+            <a:off x="0" y="0"/>
+            <a:ext cx="12191695" cy="6858000"/>
+          </a:xfrm>
+          <a:prstGeom prst="rect">
+            <a:avLst/>
+          </a:prstGeom>
+          <a:solidFill>
+            <a:srgbClr val="102A43"/>
+          </a:solidFill>
+          <a:ln>
+            <a:noFill/>
+          </a:ln>
+          <a:effectLst/>
+        </p:spPr>
+        <p:style>
+          <a:lnRef idx="1">
+            <a:schemeClr val="accent1"/>
+          </a:lnRef>
+          <a:fillRef idx="3">
+            <a:schemeClr val="accent1"/>
+          </a:fillRef>
+          <a:effectRef idx="2">
+            <a:schemeClr val="accent1"/>
+          </a:effectRef>
+          <a:fontRef idx="minor">
+            <a:schemeClr val="lt1"/>
+          </a:fontRef>
+        </p:style>
+        <p:txBody>
+          <a:bodyPr rtlCol="0" anchor="ctr"/>
+          <a:lstStyle/>
+          <a:p>
+            <a:pPr algn="ctr"/>
+          </a:p>
+        </p:txBody>
+      </p:sp>
+      <p:sp>
+        <p:nvSpPr>
+          <p:cNvPr id="3" name="TextBox 2"/>
+          <p:cNvSpPr txBox="1"/>
+          <p:nvPr/>
+        </p:nvSpPr>
+        <p:spPr>
+          <a:xfrm>
+            <a:off x="548640" y="548640"/>
+            <a:ext cx="11064240" cy="457200"/>
+          </a:xfrm>
+          <a:prstGeom prst="rect">
+            <a:avLst/>
+          </a:prstGeom>
+          <a:noFill/>
+        </p:spPr>
+        <p:txBody>
+          <a:bodyPr wrap="square">
+            <a:spAutoFit/>
+          </a:bodyPr>
+          <a:lstStyle/>
+          <a:p>
+            <a:r>
+              <a:rPr sz="1400" b="1">
+                <a:solidFill>
+                  <a:srgbClr val="F0B429"/>
+                </a:solidFill>
+                <a:latin typeface="Calibri"/>
+              </a:rPr>
+              <a:t>CASO 3 · DECISIÓN</a:t>
+            </a:r>
+          </a:p>
+        </p:txBody>
+      </p:sp>
+      <p:sp>
+        <p:nvSpPr>
+          <p:cNvPr id="4" name="TextBox 3"/>
+          <p:cNvSpPr txBox="1"/>
+          <p:nvPr/>
+        </p:nvSpPr>
+        <p:spPr>
+          <a:xfrm>
+            <a:off x="548640" y="1051560"/>
+            <a:ext cx="11064240" cy="822960"/>
+          </a:xfrm>
+          <a:prstGeom prst="rect">
+            <a:avLst/>
+          </a:prstGeom>
+          <a:noFill/>
+        </p:spPr>
+        <p:txBody>
+          <a:bodyPr wrap="square">
+            <a:spAutoFit/>
+          </a:bodyPr>
+          <a:lstStyle/>
+          <a:p>
+            <a:r>
+              <a:rPr sz="2600" b="1">
+                <a:solidFill>
+                  <a:srgbClr val="FFFFFF"/>
+                </a:solidFill>
+                <a:latin typeface="Cambria"/>
+              </a:rPr>
+              <a:t>Guion C: la oferta de tablas en el turno del rival</a:t>
+            </a:r>
+          </a:p>
+        </p:txBody>
+      </p:sp>
+      <p:sp>
+        <p:nvSpPr>
+          <p:cNvPr id="5" name="TextBox 4"/>
+          <p:cNvSpPr txBox="1"/>
+          <p:nvPr/>
+        </p:nvSpPr>
+        <p:spPr>
+          <a:xfrm>
+            <a:off x="548640" y="2103120"/>
+            <a:ext cx="11064240" cy="3931920"/>
+          </a:xfrm>
+          <a:prstGeom prst="rect">
+            <a:avLst/>
+          </a:prstGeom>
+          <a:noFill/>
+        </p:spPr>
+        <p:txBody>
+          <a:bodyPr wrap="square">
+            <a:spAutoFit/>
+          </a:bodyPr>
+          <a:lstStyle/>
+          <a:p>
+            <a:r>
+              <a:rPr sz="2000" b="0">
+                <a:solidFill>
+                  <a:srgbClr val="CADCFC"/>
+                </a:solidFill>
+                <a:latin typeface="Calibri"/>
+              </a:rPr>
+              <a:t>La oferta es válida, pero hacerla en el turno del rival es una molestia: se le recuerda el procedimiento correcto (jugada, oferta y reloj) y, si se repite, se sanciona según el art. 12.9.</a:t>
+            </a:r>
+          </a:p>
+        </p:txBody>
+      </p:sp>
+      <p:sp>
+        <p:nvSpPr>
+          <p:cNvPr id="6" name="TextBox 5"/>
+          <p:cNvSpPr txBox="1"/>
+          <p:nvPr/>
+        </p:nvSpPr>
+        <p:spPr>
+          <a:xfrm>
+            <a:off x="548640" y="6263640"/>
+            <a:ext cx="11064240" cy="365760"/>
+          </a:xfrm>
+          <a:prstGeom prst="rect">
+            <a:avLst/>
+          </a:prstGeom>
+          <a:noFill/>
+        </p:spPr>
+        <p:txBody>
+          <a:bodyPr wrap="square">
+            <a:spAutoFit/>
+          </a:bodyPr>
+          <a:lstStyle/>
+          <a:p>
+            <a:r>
+              <a:rPr sz="1100" b="0">
+                <a:solidFill>
+                  <a:srgbClr val="9FB3C8"/>
+                </a:solidFill>
+                <a:latin typeface="Calibri"/>
+              </a:rPr>
+              <a:t>Fuente: Leyes del Ajedrez 2023 (Handbook E.I.01), art. 9.1.2 y 11.5</a:t>
+            </a:r>
+          </a:p>
+        </p:txBody>
+      </p:sp>
+    </p:spTree>
+  </p:cSld>
+  <p:clrMapOvr>
+    <a:masterClrMapping/>
+  </p:clrMapOvr>
+</p:sld>
+</file>
+
+<file path=ppt/slides/slide13.xml><?xml version="1.0" encoding="utf-8"?>
+<p:sld xmlns:a="http://schemas.openxmlformats.org/drawingml/2006/main" xmlns:p="http://schemas.openxmlformats.org/presentationml/2006/main" xmlns:r="http://schemas.openxmlformats.org/officeDocument/2006/relationships">
+  <p:cSld>
+    <p:spTree>
+      <p:nvGrpSpPr>
+        <p:cNvPr id="1" name=""/>
+        <p:cNvGrpSpPr/>
+        <p:nvPr/>
+      </p:nvGrpSpPr>
+      <p:grpSpPr/>
+      <p:sp>
+        <p:nvSpPr>
+          <p:cNvPr id="2" name="Oval 1"/>
+          <p:cNvSpPr/>
+          <p:nvPr/>
+        </p:nvSpPr>
+        <p:spPr>
+          <a:xfrm>
+            <a:off x="548640" y="502920"/>
+            <a:ext cx="502920" cy="502920"/>
+          </a:xfrm>
+          <a:prstGeom prst="ellipse">
+            <a:avLst/>
+          </a:prstGeom>
+          <a:solidFill>
+            <a:srgbClr val="DE911D"/>
+          </a:solidFill>
+          <a:ln>
+            <a:noFill/>
+          </a:ln>
+          <a:effectLst/>
+        </p:spPr>
+        <p:style>
+          <a:lnRef idx="1">
+            <a:schemeClr val="accent1"/>
+          </a:lnRef>
+          <a:fillRef idx="3">
+            <a:schemeClr val="accent1"/>
+          </a:fillRef>
+          <a:effectRef idx="2">
+            <a:schemeClr val="accent1"/>
+          </a:effectRef>
+          <a:fontRef idx="minor">
+            <a:schemeClr val="lt1"/>
+          </a:fontRef>
+        </p:style>
+        <p:txBody>
+          <a:bodyPr rtlCol="0" anchor="ctr"/>
+          <a:lstStyle/>
+          <a:p>
+            <a:pPr algn="ctr"/>
+          </a:p>
+        </p:txBody>
+      </p:sp>
+      <p:sp>
+        <p:nvSpPr>
+          <p:cNvPr id="3" name="TextBox 2"/>
+          <p:cNvSpPr txBox="1"/>
+          <p:nvPr/>
+        </p:nvSpPr>
+        <p:spPr>
+          <a:xfrm>
+            <a:off x="548640" y="502920"/>
+            <a:ext cx="502920" cy="502920"/>
+          </a:xfrm>
+          <a:prstGeom prst="rect">
+            <a:avLst/>
+          </a:prstGeom>
+          <a:noFill/>
+        </p:spPr>
+        <p:txBody>
+          <a:bodyPr wrap="square">
+            <a:spAutoFit/>
+          </a:bodyPr>
+          <a:lstStyle/>
+          <a:p>
+            <a:pPr algn="ctr"/>
+            <a:r>
+              <a:rPr sz="2000" b="0">
+                <a:solidFill>
+                  <a:srgbClr val="0A1F33"/>
+                </a:solidFill>
+                <a:latin typeface="Calibri"/>
+              </a:rPr>
+              <a:t>?</a:t>
+            </a:r>
+          </a:p>
+        </p:txBody>
+      </p:sp>
+      <p:sp>
+        <p:nvSpPr>
+          <p:cNvPr id="4" name="TextBox 3"/>
+          <p:cNvSpPr txBox="1"/>
+          <p:nvPr/>
+        </p:nvSpPr>
+        <p:spPr>
+          <a:xfrm>
+            <a:off x="1234440" y="530352"/>
+            <a:ext cx="9144000" cy="457200"/>
+          </a:xfrm>
+          <a:prstGeom prst="rect">
+            <a:avLst/>
+          </a:prstGeom>
+          <a:noFill/>
+        </p:spPr>
+        <p:txBody>
+          <a:bodyPr wrap="square">
+            <a:spAutoFit/>
+          </a:bodyPr>
+          <a:lstStyle/>
+          <a:p>
+            <a:r>
+              <a:rPr sz="1400" b="1">
+                <a:solidFill>
+                  <a:srgbClr val="DE911D"/>
+                </a:solidFill>
+                <a:latin typeface="Calibri"/>
+              </a:rPr>
+              <a:t>CASO 4 · ¿QUÉ DECIDE LA PERSONA ÁRBITRA?</a:t>
+            </a:r>
+          </a:p>
+        </p:txBody>
+      </p:sp>
+      <p:sp>
+        <p:nvSpPr>
+          <p:cNvPr id="5" name="TextBox 4"/>
+          <p:cNvSpPr txBox="1"/>
+          <p:nvPr/>
+        </p:nvSpPr>
+        <p:spPr>
+          <a:xfrm>
+            <a:off x="548640" y="1051560"/>
+            <a:ext cx="11064240" cy="822960"/>
+          </a:xfrm>
+          <a:prstGeom prst="rect">
+            <a:avLst/>
+          </a:prstGeom>
+          <a:noFill/>
+        </p:spPr>
+        <p:txBody>
+          <a:bodyPr wrap="square">
+            <a:spAutoFit/>
+          </a:bodyPr>
+          <a:lstStyle/>
+          <a:p>
+            <a:r>
+              <a:rPr sz="2600" b="1">
+                <a:solidFill>
+                  <a:srgbClr val="0A1F33"/>
+                </a:solidFill>
+                <a:latin typeface="Cambria"/>
+              </a:rPr>
+              <a:t>Guion D: el público que ayuda</a:t>
+            </a:r>
+          </a:p>
+        </p:txBody>
+      </p:sp>
+      <p:sp>
+        <p:nvSpPr>
+          <p:cNvPr id="6" name="Rectangle 5"/>
+          <p:cNvSpPr/>
+          <p:nvPr/>
+        </p:nvSpPr>
+        <p:spPr>
+          <a:xfrm>
+            <a:off x="548640" y="1965960"/>
+            <a:ext cx="11064240" cy="4206240"/>
+          </a:xfrm>
+          <a:prstGeom prst="rect">
+            <a:avLst/>
+          </a:prstGeom>
+          <a:solidFill>
+            <a:srgbClr val="F0F4F8"/>
+          </a:solidFill>
+          <a:ln>
+            <a:noFill/>
+          </a:ln>
+          <a:effectLst/>
+        </p:spPr>
+        <p:style>
+          <a:lnRef idx="1">
+            <a:schemeClr val="accent1"/>
+          </a:lnRef>
+          <a:fillRef idx="3">
+            <a:schemeClr val="accent1"/>
+          </a:fillRef>
+          <a:effectRef idx="2">
+            <a:schemeClr val="accent1"/>
+          </a:effectRef>
+          <a:fontRef idx="minor">
+            <a:schemeClr val="lt1"/>
+          </a:fontRef>
+        </p:style>
+        <p:txBody>
+          <a:bodyPr rtlCol="0" anchor="ctr"/>
+          <a:lstStyle/>
+          <a:p>
+            <a:pPr algn="ctr"/>
+          </a:p>
+        </p:txBody>
+      </p:sp>
+      <p:sp>
+        <p:nvSpPr>
+          <p:cNvPr id="7" name="TextBox 6"/>
+          <p:cNvSpPr txBox="1"/>
+          <p:nvPr/>
+        </p:nvSpPr>
+        <p:spPr>
+          <a:xfrm>
+            <a:off x="914400" y="2240280"/>
+            <a:ext cx="10332720" cy="3749039"/>
+          </a:xfrm>
+          <a:prstGeom prst="rect">
+            <a:avLst/>
+          </a:prstGeom>
+          <a:noFill/>
+        </p:spPr>
+        <p:txBody>
+          <a:bodyPr wrap="square">
+            <a:spAutoFit/>
+          </a:bodyPr>
+          <a:lstStyle/>
+          <a:p>
+            <a:r>
+              <a:rPr sz="2000" b="0">
+                <a:solidFill>
+                  <a:srgbClr val="334E68"/>
+                </a:solidFill>
+                <a:latin typeface="Calibri"/>
+              </a:rPr>
+              <a:t>Un docente acompañante comenta en voz baja con su estudiante una partida en curso.</a:t>
+            </a:r>
+          </a:p>
+        </p:txBody>
+      </p:sp>
+    </p:spTree>
+  </p:cSld>
+  <p:clrMapOvr>
+    <a:masterClrMapping/>
+  </p:clrMapOvr>
+</p:sld>
+</file>
+
+<file path=ppt/slides/slide14.xml><?xml version="1.0" encoding="utf-8"?>
+<p:sld xmlns:a="http://schemas.openxmlformats.org/drawingml/2006/main" xmlns:p="http://schemas.openxmlformats.org/presentationml/2006/main" xmlns:r="http://schemas.openxmlformats.org/officeDocument/2006/relationships">
+  <p:cSld>
+    <p:spTree>
+      <p:nvGrpSpPr>
+        <p:cNvPr id="1" name=""/>
+        <p:cNvGrpSpPr/>
+        <p:nvPr/>
+      </p:nvGrpSpPr>
+      <p:grpSpPr/>
+      <p:sp>
+        <p:nvSpPr>
+          <p:cNvPr id="2" name="Rectangle 1"/>
+          <p:cNvSpPr/>
+          <p:nvPr/>
+        </p:nvSpPr>
+        <p:spPr>
+          <a:xfrm>
+            <a:off x="0" y="0"/>
+            <a:ext cx="12191695" cy="6858000"/>
+          </a:xfrm>
+          <a:prstGeom prst="rect">
+            <a:avLst/>
+          </a:prstGeom>
+          <a:solidFill>
+            <a:srgbClr val="102A43"/>
+          </a:solidFill>
+          <a:ln>
+            <a:noFill/>
+          </a:ln>
+          <a:effectLst/>
+        </p:spPr>
+        <p:style>
+          <a:lnRef idx="1">
+            <a:schemeClr val="accent1"/>
+          </a:lnRef>
+          <a:fillRef idx="3">
+            <a:schemeClr val="accent1"/>
+          </a:fillRef>
+          <a:effectRef idx="2">
+            <a:schemeClr val="accent1"/>
+          </a:effectRef>
+          <a:fontRef idx="minor">
+            <a:schemeClr val="lt1"/>
+          </a:fontRef>
+        </p:style>
+        <p:txBody>
+          <a:bodyPr rtlCol="0" anchor="ctr"/>
+          <a:lstStyle/>
+          <a:p>
+            <a:pPr algn="ctr"/>
+          </a:p>
+        </p:txBody>
+      </p:sp>
+      <p:sp>
+        <p:nvSpPr>
+          <p:cNvPr id="3" name="TextBox 2"/>
+          <p:cNvSpPr txBox="1"/>
+          <p:nvPr/>
+        </p:nvSpPr>
+        <p:spPr>
+          <a:xfrm>
+            <a:off x="548640" y="548640"/>
+            <a:ext cx="11064240" cy="457200"/>
+          </a:xfrm>
+          <a:prstGeom prst="rect">
+            <a:avLst/>
+          </a:prstGeom>
+          <a:noFill/>
+        </p:spPr>
+        <p:txBody>
+          <a:bodyPr wrap="square">
+            <a:spAutoFit/>
+          </a:bodyPr>
+          <a:lstStyle/>
+          <a:p>
+            <a:r>
+              <a:rPr sz="1400" b="1">
+                <a:solidFill>
+                  <a:srgbClr val="F0B429"/>
+                </a:solidFill>
+                <a:latin typeface="Calibri"/>
+              </a:rPr>
+              <a:t>CASO 4 · DECISIÓN</a:t>
+            </a:r>
+          </a:p>
+        </p:txBody>
+      </p:sp>
+      <p:sp>
+        <p:nvSpPr>
+          <p:cNvPr id="4" name="TextBox 3"/>
+          <p:cNvSpPr txBox="1"/>
+          <p:nvPr/>
+        </p:nvSpPr>
+        <p:spPr>
+          <a:xfrm>
+            <a:off x="548640" y="1051560"/>
+            <a:ext cx="11064240" cy="822960"/>
+          </a:xfrm>
+          <a:prstGeom prst="rect">
+            <a:avLst/>
+          </a:prstGeom>
+          <a:noFill/>
+        </p:spPr>
+        <p:txBody>
+          <a:bodyPr wrap="square">
+            <a:spAutoFit/>
+          </a:bodyPr>
+          <a:lstStyle/>
+          <a:p>
+            <a:r>
+              <a:rPr sz="2600" b="1">
+                <a:solidFill>
+                  <a:srgbClr val="FFFFFF"/>
+                </a:solidFill>
+                <a:latin typeface="Cambria"/>
+              </a:rPr>
+              <a:t>Guion D: el público que ayuda</a:t>
+            </a:r>
+          </a:p>
+        </p:txBody>
+      </p:sp>
+      <p:sp>
+        <p:nvSpPr>
+          <p:cNvPr id="5" name="TextBox 4"/>
+          <p:cNvSpPr txBox="1"/>
+          <p:nvPr/>
+        </p:nvSpPr>
+        <p:spPr>
+          <a:xfrm>
+            <a:off x="548640" y="2103120"/>
+            <a:ext cx="11064240" cy="3931920"/>
+          </a:xfrm>
+          <a:prstGeom prst="rect">
+            <a:avLst/>
+          </a:prstGeom>
+          <a:noFill/>
+        </p:spPr>
+        <p:txBody>
+          <a:bodyPr wrap="square">
+            <a:spAutoFit/>
+          </a:bodyPr>
+          <a:lstStyle/>
+          <a:p>
+            <a:r>
+              <a:rPr sz="2000" b="0">
+                <a:solidFill>
+                  <a:srgbClr val="CADCFC"/>
+                </a:solidFill>
+                <a:latin typeface="Calibri"/>
+              </a:rPr>
+              <a:t>Se retira al docente de la zona de juego; si hubo ayuda, se sanciona al estudiante según el art. 12.9. Se registra la incidencia.</a:t>
+            </a:r>
+          </a:p>
+        </p:txBody>
+      </p:sp>
+      <p:sp>
+        <p:nvSpPr>
+          <p:cNvPr id="6" name="TextBox 5"/>
+          <p:cNvSpPr txBox="1"/>
+          <p:nvPr/>
+        </p:nvSpPr>
+        <p:spPr>
+          <a:xfrm>
+            <a:off x="548640" y="6263640"/>
+            <a:ext cx="11064240" cy="365760"/>
+          </a:xfrm>
+          <a:prstGeom prst="rect">
+            <a:avLst/>
+          </a:prstGeom>
+          <a:noFill/>
+        </p:spPr>
+        <p:txBody>
+          <a:bodyPr wrap="square">
+            <a:spAutoFit/>
+          </a:bodyPr>
+          <a:lstStyle/>
+          <a:p>
+            <a:r>
+              <a:rPr sz="1100" b="0">
+                <a:solidFill>
+                  <a:srgbClr val="9FB3C8"/>
+                </a:solidFill>
+                <a:latin typeface="Calibri"/>
+              </a:rPr>
+              <a:t>Fuente: Leyes del Ajedrez 2023 (Handbook E.I.01), art. 11.3.1 y 12.7</a:t>
+            </a:r>
+          </a:p>
+        </p:txBody>
+      </p:sp>
+    </p:spTree>
+  </p:cSld>
+  <p:clrMapOvr>
+    <a:masterClrMapping/>
+  </p:clrMapOvr>
+</p:sld>
+</file>
+
+<file path=ppt/slides/slide15.xml><?xml version="1.0" encoding="utf-8"?>
+<p:sld xmlns:a="http://schemas.openxmlformats.org/drawingml/2006/main" xmlns:p="http://schemas.openxmlformats.org/presentationml/2006/main" xmlns:r="http://schemas.openxmlformats.org/officeDocument/2006/relationships">
+  <p:cSld>
+    <p:spTree>
+      <p:nvGrpSpPr>
+        <p:cNvPr id="1" name=""/>
+        <p:cNvGrpSpPr/>
+        <p:nvPr/>
+      </p:nvGrpSpPr>
+      <p:grpSpPr/>
+      <p:sp>
+        <p:nvSpPr>
+          <p:cNvPr id="2" name="Rectangle 1"/>
+          <p:cNvSpPr/>
+          <p:nvPr/>
+        </p:nvSpPr>
+        <p:spPr>
+          <a:xfrm>
+            <a:off x="0" y="0"/>
+            <a:ext cx="12191695" cy="6858000"/>
+          </a:xfrm>
+          <a:prstGeom prst="rect">
+            <a:avLst/>
+          </a:prstGeom>
+          <a:solidFill>
+            <a:srgbClr val="102A43"/>
+          </a:solidFill>
+          <a:ln>
+            <a:noFill/>
+          </a:ln>
+          <a:effectLst/>
+        </p:spPr>
+        <p:style>
+          <a:lnRef idx="1">
+            <a:schemeClr val="accent1"/>
+          </a:lnRef>
+          <a:fillRef idx="3">
+            <a:schemeClr val="accent1"/>
+          </a:fillRef>
+          <a:effectRef idx="2">
+            <a:schemeClr val="accent1"/>
+          </a:effectRef>
+          <a:fontRef idx="minor">
+            <a:schemeClr val="lt1"/>
+          </a:fontRef>
+        </p:style>
+        <p:txBody>
+          <a:bodyPr rtlCol="0" anchor="ctr"/>
+          <a:lstStyle/>
+          <a:p>
+            <a:pPr algn="ctr"/>
+          </a:p>
+        </p:txBody>
+      </p:sp>
+      <p:sp>
+        <p:nvSpPr>
+          <p:cNvPr id="3" name="Oval 2"/>
+          <p:cNvSpPr/>
+          <p:nvPr/>
+        </p:nvSpPr>
+        <p:spPr>
+          <a:xfrm>
+            <a:off x="-1280160" y="-1463040"/>
+            <a:ext cx="4114800" cy="4114800"/>
+          </a:xfrm>
+          <a:prstGeom prst="ellipse">
+            <a:avLst/>
+          </a:prstGeom>
+          <a:solidFill>
+            <a:srgbClr val="0A1F33"/>
+          </a:solidFill>
+          <a:ln>
+            <a:noFill/>
+          </a:ln>
+          <a:effectLst/>
+        </p:spPr>
+        <p:style>
+          <a:lnRef idx="1">
+            <a:schemeClr val="accent1"/>
+          </a:lnRef>
+          <a:fillRef idx="3">
+            <a:schemeClr val="accent1"/>
+          </a:fillRef>
+          <a:effectRef idx="2">
+            <a:schemeClr val="accent1"/>
+          </a:effectRef>
+          <a:fontRef idx="minor">
+            <a:schemeClr val="lt1"/>
+          </a:fontRef>
+        </p:style>
+        <p:txBody>
+          <a:bodyPr rtlCol="0" anchor="ctr"/>
+          <a:lstStyle/>
+          <a:p>
+            <a:pPr algn="ctr"/>
+          </a:p>
+        </p:txBody>
+      </p:sp>
+      <p:sp>
+        <p:nvSpPr>
+          <p:cNvPr id="4" name="Oval 3"/>
+          <p:cNvSpPr/>
+          <p:nvPr/>
+        </p:nvSpPr>
+        <p:spPr>
+          <a:xfrm>
+            <a:off x="5175504" y="822960"/>
+            <a:ext cx="1828800" cy="1828800"/>
+          </a:xfrm>
+          <a:prstGeom prst="ellipse">
+            <a:avLst/>
+          </a:prstGeom>
+          <a:solidFill>
+            <a:srgbClr val="DE911D"/>
+          </a:solidFill>
+          <a:ln>
+            <a:noFill/>
+          </a:ln>
+          <a:effectLst/>
+        </p:spPr>
+        <p:style>
+          <a:lnRef idx="1">
+            <a:schemeClr val="accent1"/>
+          </a:lnRef>
+          <a:fillRef idx="3">
+            <a:schemeClr val="accent1"/>
+          </a:fillRef>
+          <a:effectRef idx="2">
+            <a:schemeClr val="accent1"/>
+          </a:effectRef>
+          <a:fontRef idx="minor">
+            <a:schemeClr val="lt1"/>
+          </a:fontRef>
+        </p:style>
+        <p:txBody>
+          <a:bodyPr rtlCol="0" anchor="ctr"/>
+          <a:lstStyle/>
+          <a:p>
+            <a:pPr algn="ctr"/>
+          </a:p>
+        </p:txBody>
+      </p:sp>
+      <p:sp>
+        <p:nvSpPr>
+          <p:cNvPr id="5" name="TextBox 4"/>
+          <p:cNvSpPr txBox="1"/>
+          <p:nvPr/>
+        </p:nvSpPr>
+        <p:spPr>
+          <a:xfrm>
+            <a:off x="5175504" y="822960"/>
+            <a:ext cx="1828800" cy="1828800"/>
+          </a:xfrm>
+          <a:prstGeom prst="rect">
+            <a:avLst/>
+          </a:prstGeom>
+          <a:noFill/>
+        </p:spPr>
+        <p:txBody>
+          <a:bodyPr wrap="square">
+            <a:spAutoFit/>
+          </a:bodyPr>
+          <a:lstStyle/>
+          <a:p>
+            <a:pPr algn="ctr"/>
+            <a:r>
+              <a:rPr sz="4400" b="1">
+                <a:solidFill>
+                  <a:srgbClr val="0A1F33"/>
+                </a:solidFill>
+                <a:latin typeface="Calibri"/>
+              </a:rPr>
+              <a:t>✔</a:t>
+            </a:r>
+          </a:p>
+        </p:txBody>
+      </p:sp>
+      <p:sp>
+        <p:nvSpPr>
+          <p:cNvPr id="6" name="TextBox 5"/>
+          <p:cNvSpPr txBox="1"/>
+          <p:nvPr/>
+        </p:nvSpPr>
+        <p:spPr>
+          <a:xfrm>
+            <a:off x="548640" y="2880360"/>
+            <a:ext cx="11064240" cy="457200"/>
+          </a:xfrm>
+          <a:prstGeom prst="rect">
+            <a:avLst/>
+          </a:prstGeom>
+          <a:noFill/>
+        </p:spPr>
+        <p:txBody>
+          <a:bodyPr wrap="square">
+            <a:spAutoFit/>
+          </a:bodyPr>
+          <a:lstStyle/>
+          <a:p>
+            <a:pPr algn="ctr"/>
+            <a:r>
+              <a:rPr sz="1400" b="1">
+                <a:solidFill>
+                  <a:srgbClr val="F0B429"/>
+                </a:solidFill>
+                <a:latin typeface="Calibri"/>
+              </a:rPr>
+              <a:t>PRÁCTICA — SIMULACRO DE ARBITRAJE CON OBSERVACIÓN ENTRE PARES</a:t>
+            </a:r>
+          </a:p>
+        </p:txBody>
+      </p:sp>
+      <p:sp>
+        <p:nvSpPr>
+          <p:cNvPr id="7" name="TextBox 6"/>
+          <p:cNvSpPr txBox="1"/>
+          <p:nvPr/>
+        </p:nvSpPr>
+        <p:spPr>
+          <a:xfrm>
+            <a:off x="1280160" y="3383280"/>
+            <a:ext cx="9601200" cy="2377440"/>
+          </a:xfrm>
+          <a:prstGeom prst="rect">
+            <a:avLst/>
+          </a:prstGeom>
+          <a:noFill/>
+        </p:spPr>
+        <p:txBody>
+          <a:bodyPr wrap="square">
+            <a:spAutoFit/>
+          </a:bodyPr>
+          <a:lstStyle/>
+          <a:p>
+            <a:pPr algn="ctr"/>
+            <a:r>
+              <a:rPr sz="2000" b="0">
+                <a:solidFill>
+                  <a:srgbClr val="FFFFFF"/>
+                </a:solidFill>
+                <a:latin typeface="Cambria"/>
+              </a:rPr>
+              <a:t>Cada participante arbitra una partida simulada mientras otra persona observa y completa la lista de cotejo; luego se intercambian los roles.</a:t>
+            </a:r>
+          </a:p>
+        </p:txBody>
+      </p:sp>
+      <p:sp>
+        <p:nvSpPr>
+          <p:cNvPr id="8" name="TextBox 7"/>
+          <p:cNvSpPr txBox="1"/>
+          <p:nvPr/>
+        </p:nvSpPr>
+        <p:spPr>
+          <a:xfrm>
+            <a:off x="548640" y="6263640"/>
+            <a:ext cx="11064240" cy="365760"/>
+          </a:xfrm>
+          <a:prstGeom prst="rect">
+            <a:avLst/>
+          </a:prstGeom>
+          <a:noFill/>
+        </p:spPr>
+        <p:txBody>
+          <a:bodyPr wrap="square">
+            <a:spAutoFit/>
+          </a:bodyPr>
+          <a:lstStyle/>
+          <a:p>
+            <a:pPr algn="ctr"/>
+            <a:r>
+              <a:rPr sz="1200" b="0">
+                <a:solidFill>
+                  <a:srgbClr val="9FB3C8"/>
+                </a:solidFill>
+                <a:latin typeface="Calibri"/>
+              </a:rPr>
+              <a:t>Formación Ajedrez · Sesión 7</a:t>
+            </a:r>
+          </a:p>
+        </p:txBody>
+      </p:sp>
+    </p:spTree>
+  </p:cSld>
+  <p:clrMapOvr>
+    <a:masterClrMapping/>
+  </p:clrMapOvr>
+</p:sld>
+</file>
+
+<file path=ppt/slides/slide16.xml><?xml version="1.0" encoding="utf-8"?>
+<p:sld xmlns:a="http://schemas.openxmlformats.org/drawingml/2006/main" xmlns:p="http://schemas.openxmlformats.org/presentationml/2006/main" xmlns:r="http://schemas.openxmlformats.org/officeDocument/2006/relationships">
+  <p:cSld>
+    <p:spTree>
+      <p:nvGrpSpPr>
+        <p:cNvPr id="1" name=""/>
+        <p:cNvGrpSpPr/>
+        <p:nvPr/>
+      </p:nvGrpSpPr>
+      <p:grpSpPr/>
+      <p:sp>
+        <p:nvSpPr>
+          <p:cNvPr id="2" name="Oval 1"/>
+          <p:cNvSpPr/>
+          <p:nvPr/>
+        </p:nvSpPr>
+        <p:spPr>
+          <a:xfrm>
+            <a:off x="548640" y="502920"/>
+            <a:ext cx="502920" cy="502920"/>
+          </a:xfrm>
+          <a:prstGeom prst="ellipse">
+            <a:avLst/>
+          </a:prstGeom>
+          <a:solidFill>
+            <a:srgbClr val="DE911D"/>
+          </a:solidFill>
+          <a:ln>
+            <a:noFill/>
+          </a:ln>
+          <a:effectLst/>
+        </p:spPr>
+        <p:style>
+          <a:lnRef idx="1">
+            <a:schemeClr val="accent1"/>
+          </a:lnRef>
+          <a:fillRef idx="3">
+            <a:schemeClr val="accent1"/>
+          </a:fillRef>
+          <a:effectRef idx="2">
+            <a:schemeClr val="accent1"/>
+          </a:effectRef>
+          <a:fontRef idx="minor">
+            <a:schemeClr val="lt1"/>
+          </a:fontRef>
+        </p:style>
+        <p:txBody>
+          <a:bodyPr rtlCol="0" anchor="ctr"/>
+          <a:lstStyle/>
+          <a:p>
+            <a:pPr algn="ctr"/>
+          </a:p>
+        </p:txBody>
+      </p:sp>
+      <p:sp>
+        <p:nvSpPr>
+          <p:cNvPr id="3" name="TextBox 2"/>
+          <p:cNvSpPr txBox="1"/>
+          <p:nvPr/>
+        </p:nvSpPr>
+        <p:spPr>
+          <a:xfrm>
+            <a:off x="548640" y="502920"/>
+            <a:ext cx="502920" cy="502920"/>
+          </a:xfrm>
+          <a:prstGeom prst="rect">
+            <a:avLst/>
+          </a:prstGeom>
+          <a:noFill/>
+        </p:spPr>
+        <p:txBody>
+          <a:bodyPr wrap="square">
+            <a:spAutoFit/>
+          </a:bodyPr>
+          <a:lstStyle/>
+          <a:p>
+            <a:pPr algn="ctr"/>
+            <a:r>
+              <a:rPr sz="2000" b="0">
+                <a:solidFill>
+                  <a:srgbClr val="0A1F33"/>
+                </a:solidFill>
+                <a:latin typeface="Calibri"/>
+              </a:rPr>
+              <a:t>✎</a:t>
+            </a:r>
+          </a:p>
+        </p:txBody>
+      </p:sp>
+      <p:sp>
+        <p:nvSpPr>
+          <p:cNvPr id="4" name="TextBox 3"/>
+          <p:cNvSpPr txBox="1"/>
+          <p:nvPr/>
+        </p:nvSpPr>
+        <p:spPr>
+          <a:xfrm>
+            <a:off x="1234440" y="530352"/>
+            <a:ext cx="9144000" cy="457200"/>
+          </a:xfrm>
+          <a:prstGeom prst="rect">
+            <a:avLst/>
+          </a:prstGeom>
+          <a:noFill/>
+        </p:spPr>
+        <p:txBody>
+          <a:bodyPr wrap="square">
+            <a:spAutoFit/>
+          </a:bodyPr>
+          <a:lstStyle/>
+          <a:p>
+            <a:r>
+              <a:rPr sz="1400" b="1">
+                <a:solidFill>
+                  <a:srgbClr val="DE911D"/>
+                </a:solidFill>
+                <a:latin typeface="Calibri"/>
+              </a:rPr>
+              <a:t>EJERCICIO 1 DE 2</a:t>
+            </a:r>
+          </a:p>
+        </p:txBody>
+      </p:sp>
+      <p:sp>
+        <p:nvSpPr>
+          <p:cNvPr id="5" name="Rectangle 4"/>
+          <p:cNvSpPr/>
+          <p:nvPr/>
+        </p:nvSpPr>
+        <p:spPr>
+          <a:xfrm>
+            <a:off x="548640" y="1188720"/>
+            <a:ext cx="11064240" cy="5029200"/>
+          </a:xfrm>
+          <a:prstGeom prst="rect">
+            <a:avLst/>
+          </a:prstGeom>
+          <a:solidFill>
+            <a:srgbClr val="F0F4F8"/>
+          </a:solidFill>
+          <a:ln>
+            <a:noFill/>
+          </a:ln>
+          <a:effectLst/>
+        </p:spPr>
+        <p:style>
+          <a:lnRef idx="1">
+            <a:schemeClr val="accent1"/>
+          </a:lnRef>
+          <a:fillRef idx="3">
+            <a:schemeClr val="accent1"/>
+          </a:fillRef>
+          <a:effectRef idx="2">
+            <a:schemeClr val="accent1"/>
+          </a:effectRef>
+          <a:fontRef idx="minor">
+            <a:schemeClr val="lt1"/>
+          </a:fontRef>
+        </p:style>
+        <p:txBody>
+          <a:bodyPr rtlCol="0" anchor="ctr"/>
+          <a:lstStyle/>
+          <a:p>
+            <a:pPr algn="ctr"/>
+          </a:p>
+        </p:txBody>
+      </p:sp>
+      <p:sp>
+        <p:nvSpPr>
+          <p:cNvPr id="6" name="TextBox 5"/>
+          <p:cNvSpPr txBox="1"/>
+          <p:nvPr/>
+        </p:nvSpPr>
+        <p:spPr>
+          <a:xfrm>
+            <a:off x="914400" y="1554480"/>
+            <a:ext cx="10332720" cy="4480560"/>
+          </a:xfrm>
+          <a:prstGeom prst="rect">
+            <a:avLst/>
+          </a:prstGeom>
+          <a:noFill/>
+        </p:spPr>
+        <p:txBody>
+          <a:bodyPr wrap="square">
+            <a:spAutoFit/>
+          </a:bodyPr>
+          <a:lstStyle/>
+          <a:p>
+            <a:r>
+              <a:rPr sz="2200" b="0">
+                <a:solidFill>
+                  <a:srgbClr val="0A1F33"/>
+                </a:solidFill>
+                <a:latin typeface="Calibri"/>
+              </a:rPr>
+              <a:t>Durante el simulacro, la persona árbitra resolvió bien un reclamo, pero no lo anotó en el acta. ¿Cómo lo marcas en la lista de cotejo?</a:t>
+            </a:r>
+          </a:p>
+        </p:txBody>
+      </p:sp>
+    </p:spTree>
+  </p:cSld>
+  <p:clrMapOvr>
+    <a:masterClrMapping/>
+  </p:clrMapOvr>
+</p:sld>
+</file>
+
+<file path=ppt/slides/slide17.xml><?xml version="1.0" encoding="utf-8"?>
+<p:sld xmlns:a="http://schemas.openxmlformats.org/drawingml/2006/main" xmlns:p="http://schemas.openxmlformats.org/presentationml/2006/main" xmlns:r="http://schemas.openxmlformats.org/officeDocument/2006/relationships">
+  <p:cSld>
+    <p:spTree>
+      <p:nvGrpSpPr>
+        <p:cNvPr id="1" name=""/>
+        <p:cNvGrpSpPr/>
+        <p:nvPr/>
+      </p:nvGrpSpPr>
+      <p:grpSpPr/>
+      <p:sp>
+        <p:nvSpPr>
+          <p:cNvPr id="2" name="Oval 1"/>
+          <p:cNvSpPr/>
+          <p:nvPr/>
+        </p:nvSpPr>
+        <p:spPr>
+          <a:xfrm>
+            <a:off x="548640" y="502920"/>
+            <a:ext cx="502920" cy="502920"/>
+          </a:xfrm>
+          <a:prstGeom prst="ellipse">
+            <a:avLst/>
+          </a:prstGeom>
+          <a:solidFill>
+            <a:srgbClr val="DE911D"/>
+          </a:solidFill>
+          <a:ln>
+            <a:noFill/>
+          </a:ln>
+          <a:effectLst/>
+        </p:spPr>
+        <p:style>
+          <a:lnRef idx="1">
+            <a:schemeClr val="accent1"/>
+          </a:lnRef>
+          <a:fillRef idx="3">
+            <a:schemeClr val="accent1"/>
+          </a:fillRef>
+          <a:effectRef idx="2">
+            <a:schemeClr val="accent1"/>
+          </a:effectRef>
+          <a:fontRef idx="minor">
+            <a:schemeClr val="lt1"/>
+          </a:fontRef>
+        </p:style>
+        <p:txBody>
+          <a:bodyPr rtlCol="0" anchor="ctr"/>
+          <a:lstStyle/>
+          <a:p>
+            <a:pPr algn="ctr"/>
+          </a:p>
+        </p:txBody>
+      </p:sp>
+      <p:sp>
+        <p:nvSpPr>
+          <p:cNvPr id="3" name="TextBox 2"/>
+          <p:cNvSpPr txBox="1"/>
+          <p:nvPr/>
+        </p:nvSpPr>
+        <p:spPr>
+          <a:xfrm>
+            <a:off x="548640" y="502920"/>
+            <a:ext cx="502920" cy="502920"/>
+          </a:xfrm>
+          <a:prstGeom prst="rect">
+            <a:avLst/>
+          </a:prstGeom>
+          <a:noFill/>
+        </p:spPr>
+        <p:txBody>
+          <a:bodyPr wrap="square">
+            <a:spAutoFit/>
+          </a:bodyPr>
+          <a:lstStyle/>
+          <a:p>
+            <a:pPr algn="ctr"/>
+            <a:r>
+              <a:rPr sz="2000" b="0">
+                <a:solidFill>
+                  <a:srgbClr val="0A1F33"/>
+                </a:solidFill>
+                <a:latin typeface="Calibri"/>
+              </a:rPr>
+              <a:t>✎</a:t>
+            </a:r>
+          </a:p>
+        </p:txBody>
+      </p:sp>
+      <p:sp>
+        <p:nvSpPr>
+          <p:cNvPr id="4" name="TextBox 3"/>
+          <p:cNvSpPr txBox="1"/>
+          <p:nvPr/>
+        </p:nvSpPr>
+        <p:spPr>
+          <a:xfrm>
+            <a:off x="1234440" y="530352"/>
+            <a:ext cx="9144000" cy="457200"/>
+          </a:xfrm>
+          <a:prstGeom prst="rect">
+            <a:avLst/>
+          </a:prstGeom>
+          <a:noFill/>
+        </p:spPr>
+        <p:txBody>
+          <a:bodyPr wrap="square">
+            <a:spAutoFit/>
+          </a:bodyPr>
+          <a:lstStyle/>
+          <a:p>
+            <a:r>
+              <a:rPr sz="1400" b="1">
+                <a:solidFill>
+                  <a:srgbClr val="DE911D"/>
+                </a:solidFill>
+                <a:latin typeface="Calibri"/>
+              </a:rPr>
+              <a:t>EJERCICIO 2 DE 2</a:t>
+            </a:r>
+          </a:p>
+        </p:txBody>
+      </p:sp>
+      <p:sp>
+        <p:nvSpPr>
+          <p:cNvPr id="5" name="Rectangle 4"/>
+          <p:cNvSpPr/>
+          <p:nvPr/>
+        </p:nvSpPr>
+        <p:spPr>
+          <a:xfrm>
+            <a:off x="548640" y="1188720"/>
+            <a:ext cx="11064240" cy="5029200"/>
+          </a:xfrm>
+          <a:prstGeom prst="rect">
+            <a:avLst/>
+          </a:prstGeom>
+          <a:solidFill>
+            <a:srgbClr val="F0F4F8"/>
+          </a:solidFill>
+          <a:ln>
+            <a:noFill/>
+          </a:ln>
+          <a:effectLst/>
+        </p:spPr>
+        <p:style>
+          <a:lnRef idx="1">
+            <a:schemeClr val="accent1"/>
+          </a:lnRef>
+          <a:fillRef idx="3">
+            <a:schemeClr val="accent1"/>
+          </a:fillRef>
+          <a:effectRef idx="2">
+            <a:schemeClr val="accent1"/>
+          </a:effectRef>
+          <a:fontRef idx="minor">
+            <a:schemeClr val="lt1"/>
+          </a:fontRef>
+        </p:style>
+        <p:txBody>
+          <a:bodyPr rtlCol="0" anchor="ctr"/>
+          <a:lstStyle/>
+          <a:p>
+            <a:pPr algn="ctr"/>
+          </a:p>
+        </p:txBody>
+      </p:sp>
+      <p:sp>
+        <p:nvSpPr>
+          <p:cNvPr id="6" name="TextBox 5"/>
+          <p:cNvSpPr txBox="1"/>
+          <p:nvPr/>
+        </p:nvSpPr>
+        <p:spPr>
+          <a:xfrm>
+            <a:off x="914400" y="1554480"/>
+            <a:ext cx="10332720" cy="4480560"/>
+          </a:xfrm>
+          <a:prstGeom prst="rect">
+            <a:avLst/>
+          </a:prstGeom>
+          <a:noFill/>
+        </p:spPr>
+        <p:txBody>
+          <a:bodyPr wrap="square">
+            <a:spAutoFit/>
+          </a:bodyPr>
+          <a:lstStyle/>
+          <a:p>
+            <a:r>
+              <a:rPr sz="2200" b="0">
+                <a:solidFill>
+                  <a:srgbClr val="0A1F33"/>
+                </a:solidFill>
+                <a:latin typeface="Calibri"/>
+              </a:rPr>
+              <a:t>Escribe una retroalimentación útil para una persona que aplicó la sanción máxima a una primera falta leve.</a:t>
+            </a:r>
+          </a:p>
+        </p:txBody>
+      </p:sp>
+    </p:spTree>
+  </p:cSld>
+  <p:clrMapOvr>
+    <a:masterClrMapping/>
+  </p:clrMapOvr>
+</p:sld>
+</file>
+
+<file path=ppt/slides/slide18.xml><?xml version="1.0" encoding="utf-8"?>
+<p:sld xmlns:a="http://schemas.openxmlformats.org/drawingml/2006/main" xmlns:p="http://schemas.openxmlformats.org/presentationml/2006/main" xmlns:r="http://schemas.openxmlformats.org/officeDocument/2006/relationships">
+  <p:cSld>
+    <p:spTree>
+      <p:nvGrpSpPr>
+        <p:cNvPr id="1" name=""/>
+        <p:cNvGrpSpPr/>
+        <p:nvPr/>
+      </p:nvGrpSpPr>
+      <p:grpSpPr/>
+      <p:sp>
+        <p:nvSpPr>
+          <p:cNvPr id="2" name="Oval 1"/>
+          <p:cNvSpPr/>
+          <p:nvPr/>
+        </p:nvSpPr>
+        <p:spPr>
+          <a:xfrm>
+            <a:off x="548640" y="502920"/>
+            <a:ext cx="502920" cy="502920"/>
+          </a:xfrm>
+          <a:prstGeom prst="ellipse">
+            <a:avLst/>
+          </a:prstGeom>
+          <a:solidFill>
+            <a:srgbClr val="DE911D"/>
+          </a:solidFill>
+          <a:ln>
+            <a:noFill/>
+          </a:ln>
+          <a:effectLst/>
+        </p:spPr>
+        <p:style>
+          <a:lnRef idx="1">
+            <a:schemeClr val="accent1"/>
+          </a:lnRef>
+          <a:fillRef idx="3">
+            <a:schemeClr val="accent1"/>
+          </a:fillRef>
+          <a:effectRef idx="2">
+            <a:schemeClr val="accent1"/>
+          </a:effectRef>
+          <a:fontRef idx="minor">
+            <a:schemeClr val="lt1"/>
+          </a:fontRef>
+        </p:style>
+        <p:txBody>
+          <a:bodyPr rtlCol="0" anchor="ctr"/>
+          <a:lstStyle/>
+          <a:p>
+            <a:pPr algn="ctr"/>
+          </a:p>
+        </p:txBody>
+      </p:sp>
+      <p:sp>
+        <p:nvSpPr>
+          <p:cNvPr id="3" name="TextBox 2"/>
+          <p:cNvSpPr txBox="1"/>
+          <p:nvPr/>
+        </p:nvSpPr>
+        <p:spPr>
+          <a:xfrm>
+            <a:off x="548640" y="502920"/>
+            <a:ext cx="502920" cy="502920"/>
+          </a:xfrm>
+          <a:prstGeom prst="rect">
+            <a:avLst/>
+          </a:prstGeom>
+          <a:noFill/>
+        </p:spPr>
+        <p:txBody>
+          <a:bodyPr wrap="square">
+            <a:spAutoFit/>
+          </a:bodyPr>
+          <a:lstStyle/>
+          <a:p>
+            <a:pPr algn="ctr"/>
+            <a:r>
+              <a:rPr sz="2000" b="0">
+                <a:solidFill>
+                  <a:srgbClr val="0A1F33"/>
+                </a:solidFill>
+                <a:latin typeface="Calibri"/>
+              </a:rPr>
+              <a:t>?</a:t>
+            </a:r>
+          </a:p>
+        </p:txBody>
+      </p:sp>
+      <p:sp>
+        <p:nvSpPr>
+          <p:cNvPr id="4" name="TextBox 3"/>
+          <p:cNvSpPr txBox="1"/>
+          <p:nvPr/>
+        </p:nvSpPr>
+        <p:spPr>
+          <a:xfrm>
+            <a:off x="1234440" y="530352"/>
+            <a:ext cx="9144000" cy="457200"/>
+          </a:xfrm>
+          <a:prstGeom prst="rect">
+            <a:avLst/>
+          </a:prstGeom>
+          <a:noFill/>
+        </p:spPr>
+        <p:txBody>
+          <a:bodyPr wrap="square">
+            <a:spAutoFit/>
+          </a:bodyPr>
+          <a:lstStyle/>
+          <a:p>
+            <a:r>
+              <a:rPr sz="1400" b="1">
+                <a:solidFill>
+                  <a:srgbClr val="DE911D"/>
+                </a:solidFill>
+                <a:latin typeface="Calibri"/>
+              </a:rPr>
+              <a:t>QUIZ DE LA SESIÓN</a:t>
+            </a:r>
+          </a:p>
+        </p:txBody>
+      </p:sp>
+      <p:sp>
+        <p:nvSpPr>
+          <p:cNvPr id="5" name="Rectangle 4"/>
+          <p:cNvSpPr/>
+          <p:nvPr/>
+        </p:nvSpPr>
+        <p:spPr>
+          <a:xfrm>
+            <a:off x="548640" y="1188720"/>
+            <a:ext cx="11064240" cy="5029200"/>
+          </a:xfrm>
+          <a:prstGeom prst="rect">
+            <a:avLst/>
+          </a:prstGeom>
+          <a:solidFill>
+            <a:srgbClr val="F0F4F8"/>
+          </a:solidFill>
+          <a:ln>
+            <a:noFill/>
+          </a:ln>
+          <a:effectLst/>
+        </p:spPr>
+        <p:style>
+          <a:lnRef idx="1">
+            <a:schemeClr val="accent1"/>
+          </a:lnRef>
+          <a:fillRef idx="3">
+            <a:schemeClr val="accent1"/>
+          </a:fillRef>
+          <a:effectRef idx="2">
+            <a:schemeClr val="accent1"/>
+          </a:effectRef>
+          <a:fontRef idx="minor">
+            <a:schemeClr val="lt1"/>
+          </a:fontRef>
+        </p:style>
+        <p:txBody>
+          <a:bodyPr rtlCol="0" anchor="ctr"/>
+          <a:lstStyle/>
+          <a:p>
+            <a:pPr algn="ctr"/>
+          </a:p>
+        </p:txBody>
+      </p:sp>
+      <p:sp>
+        <p:nvSpPr>
+          <p:cNvPr id="6" name="TextBox 5"/>
+          <p:cNvSpPr txBox="1"/>
+          <p:nvPr/>
+        </p:nvSpPr>
+        <p:spPr>
+          <a:xfrm>
+            <a:off x="914400" y="1371600"/>
+            <a:ext cx="10332720" cy="4754880"/>
+          </a:xfrm>
+          <a:prstGeom prst="rect">
+            <a:avLst/>
+          </a:prstGeom>
+          <a:noFill/>
+        </p:spPr>
+        <p:txBody>
+          <a:bodyPr wrap="square">
+            <a:spAutoFit/>
+          </a:bodyPr>
+          <a:lstStyle/>
+          <a:p>
+            <a:pPr>
+              <a:spcAft>
+                <a:spcPts val="600"/>
+              </a:spcAft>
+            </a:pPr>
+            <a:r>
+              <a:rPr sz="1600">
+                <a:solidFill>
+                  <a:srgbClr val="334E68"/>
+                </a:solidFill>
+                <a:latin typeface="Calibri"/>
+              </a:rPr>
+              <a:t>1. Durante un simulacro, no se aplicó la sanción por uso de dispositivo electrónico. ¿Qué instrumento documenta esa observación?</a:t>
+            </a:r>
+          </a:p>
+          <a:p>
+            <a:pPr>
+              <a:spcAft>
+                <a:spcPts val="600"/>
+              </a:spcAft>
+            </a:pPr>
+            <a:r>
+              <a:rPr sz="1600">
+                <a:solidFill>
+                  <a:srgbClr val="334E68"/>
+                </a:solidFill>
+                <a:latin typeface="Calibri"/>
+              </a:rPr>
+              <a:t>2. ¿Cuál es el propósito principal de asignar roles antes de la sesión presencial?</a:t>
+            </a:r>
+          </a:p>
+          <a:p>
+            <a:pPr>
+              <a:spcAft>
+                <a:spcPts val="600"/>
+              </a:spcAft>
+            </a:pPr>
+            <a:r>
+              <a:rPr sz="1600">
+                <a:solidFill>
+                  <a:srgbClr val="334E68"/>
+                </a:solidFill>
+                <a:latin typeface="Calibri"/>
+              </a:rPr>
+              <a:t>3. Un reclamo de triple repetición resulta incorrecto. ¿Qué efecto tiene además?</a:t>
+            </a:r>
+          </a:p>
+          <a:p>
+            <a:pPr>
+              <a:spcAft>
+                <a:spcPts val="600"/>
+              </a:spcAft>
+            </a:pPr>
+            <a:r>
+              <a:rPr sz="1600">
+                <a:solidFill>
+                  <a:srgbClr val="334E68"/>
+                </a:solidFill>
+                <a:latin typeface="Calibri"/>
+              </a:rPr>
+              <a:t>4. ¿En qué orden se ofrecen tablas correctamente?</a:t>
+            </a:r>
+          </a:p>
+        </p:txBody>
+      </p:sp>
+    </p:spTree>
+  </p:cSld>
+  <p:clrMapOvr>
+    <a:masterClrMapping/>
+  </p:clrMapOvr>
+</p:sld>
+</file>
+
+<file path=ppt/slides/slide19.xml><?xml version="1.0" encoding="utf-8"?>
+<p:sld xmlns:a="http://schemas.openxmlformats.org/drawingml/2006/main" xmlns:p="http://schemas.openxmlformats.org/presentationml/2006/main" xmlns:r="http://schemas.openxmlformats.org/officeDocument/2006/relationships">
+  <p:cSld>
+    <p:spTree>
+      <p:nvGrpSpPr>
+        <p:cNvPr id="1" name=""/>
+        <p:cNvGrpSpPr/>
+        <p:nvPr/>
+      </p:nvGrpSpPr>
+      <p:grpSpPr/>
+      <p:sp>
+        <p:nvSpPr>
+          <p:cNvPr id="2" name="Rectangle 1"/>
+          <p:cNvSpPr/>
+          <p:nvPr/>
+        </p:nvSpPr>
+        <p:spPr>
+          <a:xfrm>
+            <a:off x="0" y="0"/>
+            <a:ext cx="12191695" cy="6858000"/>
+          </a:xfrm>
+          <a:prstGeom prst="rect">
+            <a:avLst/>
+          </a:prstGeom>
+          <a:solidFill>
+            <a:srgbClr val="0A1F33"/>
+          </a:solidFill>
+          <a:ln>
+            <a:noFill/>
+          </a:ln>
+          <a:effectLst/>
+        </p:spPr>
+        <p:style>
+          <a:lnRef idx="1">
+            <a:schemeClr val="accent1"/>
+          </a:lnRef>
+          <a:fillRef idx="3">
+            <a:schemeClr val="accent1"/>
+          </a:fillRef>
+          <a:effectRef idx="2">
+            <a:schemeClr val="accent1"/>
+          </a:effectRef>
+          <a:fontRef idx="minor">
+            <a:schemeClr val="lt1"/>
+          </a:fontRef>
+        </p:style>
+        <p:txBody>
+          <a:bodyPr rtlCol="0" anchor="ctr"/>
+          <a:lstStyle/>
+          <a:p>
+            <a:pPr algn="ctr"/>
+          </a:p>
+        </p:txBody>
+      </p:sp>
+      <p:sp>
+        <p:nvSpPr>
+          <p:cNvPr id="3" name="TextBox 2"/>
+          <p:cNvSpPr txBox="1"/>
+          <p:nvPr/>
+        </p:nvSpPr>
+        <p:spPr>
+          <a:xfrm>
+            <a:off x="548640" y="731520"/>
+            <a:ext cx="11064240" cy="457200"/>
+          </a:xfrm>
+          <a:prstGeom prst="rect">
+            <a:avLst/>
+          </a:prstGeom>
+          <a:noFill/>
+        </p:spPr>
+        <p:txBody>
+          <a:bodyPr wrap="square">
+            <a:spAutoFit/>
+          </a:bodyPr>
+          <a:lstStyle/>
+          <a:p>
+            <a:r>
+              <a:rPr sz="1400" b="1">
+                <a:solidFill>
+                  <a:srgbClr val="F0B429"/>
+                </a:solidFill>
+                <a:latin typeface="Calibri"/>
+              </a:rPr>
+              <a:t>TAREA PARA LA PRÓXIMA SESIÓN</a:t>
+            </a:r>
+          </a:p>
+        </p:txBody>
+      </p:sp>
+      <p:sp>
+        <p:nvSpPr>
+          <p:cNvPr id="4" name="TextBox 3"/>
+          <p:cNvSpPr txBox="1"/>
+          <p:nvPr/>
+        </p:nvSpPr>
+        <p:spPr>
+          <a:xfrm>
+            <a:off x="548640" y="1371600"/>
+            <a:ext cx="11064240" cy="2926080"/>
+          </a:xfrm>
+          <a:prstGeom prst="rect">
+            <a:avLst/>
+          </a:prstGeom>
+          <a:noFill/>
+        </p:spPr>
+        <p:txBody>
+          <a:bodyPr wrap="square">
+            <a:spAutoFit/>
+          </a:bodyPr>
+          <a:lstStyle/>
+          <a:p>
+            <a:r>
+              <a:rPr sz="2400" b="0">
+                <a:solidFill>
+                  <a:srgbClr val="FFFFFF"/>
+                </a:solidFill>
+                <a:latin typeface="Cambria"/>
+              </a:rPr>
+              <a:t>Confirmar el rol asignado, revisar la lista de cotejo y reunir los materiales solicitados para el día presencial.</a:t>
+            </a:r>
+          </a:p>
+        </p:txBody>
+      </p:sp>
+      <p:sp>
+        <p:nvSpPr>
+          <p:cNvPr id="5" name="TextBox 4"/>
+          <p:cNvSpPr txBox="1"/>
+          <p:nvPr/>
+        </p:nvSpPr>
+        <p:spPr>
+          <a:xfrm>
+            <a:off x="548640" y="4754880"/>
+            <a:ext cx="11064240" cy="914400"/>
+          </a:xfrm>
+          <a:prstGeom prst="rect">
+            <a:avLst/>
+          </a:prstGeom>
+          <a:noFill/>
+        </p:spPr>
+        <p:txBody>
+          <a:bodyPr wrap="square">
+            <a:spAutoFit/>
+          </a:bodyPr>
+          <a:lstStyle/>
+          <a:p>
+            <a:r>
+              <a:rPr sz="1800" b="0">
+                <a:solidFill>
+                  <a:srgbClr val="CADCFC"/>
+                </a:solidFill>
+                <a:latin typeface="Calibri"/>
+              </a:rPr>
+              <a:t>¿Dudas? Este es el momento. Gracias por tu participación.</a:t>
+            </a:r>
+          </a:p>
+        </p:txBody>
+      </p:sp>
+      <p:sp>
+        <p:nvSpPr>
+          <p:cNvPr id="6" name="TextBox 5"/>
+          <p:cNvSpPr txBox="1"/>
+          <p:nvPr/>
+        </p:nvSpPr>
+        <p:spPr>
+          <a:xfrm>
+            <a:off x="548640" y="6263640"/>
+            <a:ext cx="11064240" cy="365760"/>
+          </a:xfrm>
+          <a:prstGeom prst="rect">
+            <a:avLst/>
+          </a:prstGeom>
+          <a:noFill/>
+        </p:spPr>
+        <p:txBody>
+          <a:bodyPr wrap="square">
+            <a:spAutoFit/>
+          </a:bodyPr>
+          <a:lstStyle/>
+          <a:p>
+            <a:r>
+              <a:rPr sz="1200" b="0">
+                <a:solidFill>
+                  <a:srgbClr val="9FB3C8"/>
+                </a:solidFill>
+                <a:latin typeface="Calibri"/>
+              </a:rPr>
+              <a:t>Formación Ajedrez · Sesión 7 · ajedrez-integral.com</a:t>
+            </a:r>
+          </a:p>
+        </p:txBody>
+      </p:sp>
+    </p:spTree>
+  </p:cSld>
+  <p:clrMapOvr>
+    <a:masterClrMapping/>
+  </p:clrMapOvr>
+</p:sld>
+</file>
+
 <file path=ppt/slides/slide2.xml><?xml version="1.0" encoding="utf-8"?>
 <p:sld xmlns:a="http://schemas.openxmlformats.org/drawingml/2006/main" xmlns:p="http://schemas.openxmlformats.org/presentationml/2006/main" xmlns:r="http://schemas.openxmlformats.org/officeDocument/2006/relationships">
   <p:cSld>
@@ -3565,7 +5827,7 @@
                 </a:solidFill>
                 <a:latin typeface="Calibri"/>
               </a:rPr>
-              <a:t>⚖</a:t>
+              <a:t>◎</a:t>
             </a:r>
           </a:p>
         </p:txBody>
@@ -3579,7 +5841,7 @@
         <p:spPr>
           <a:xfrm>
             <a:off x="1234440" y="530352"/>
-            <a:ext cx="7315200" cy="457200"/>
+            <a:ext cx="9144000" cy="457200"/>
           </a:xfrm>
           <a:prstGeom prst="rect">
             <a:avLst/>
@@ -3599,7 +5861,7 @@
                 </a:solidFill>
                 <a:latin typeface="Calibri"/>
               </a:rPr>
-              <a:t>CONTENIDO DE LA SESIÓN</a:t>
+              <a:t>OBJETIVOS DE LA SESIÓN</a:t>
             </a:r>
           </a:p>
         </p:txBody>
@@ -3690,8 +5952,8 @@
         </p:nvSpPr>
         <p:spPr>
           <a:xfrm>
-            <a:off x="1005840" y="2331720"/>
-            <a:ext cx="10241280" cy="3566160"/>
+            <a:off x="914400" y="2194560"/>
+            <a:ext cx="10332720" cy="3931920"/>
           </a:xfrm>
           <a:prstGeom prst="rect">
             <a:avLst/>
@@ -3704,14 +5966,67 @@
           </a:bodyPr>
           <a:lstStyle/>
           <a:p>
-            <a:r>
-              <a:rPr sz="1600" b="0">
+            <a:pPr>
+              <a:spcAft>
+                <a:spcPts val="800"/>
+              </a:spcAft>
+            </a:pPr>
+            <a:r>
+              <a:rPr sz="1800">
                 <a:solidFill>
                   <a:srgbClr val="334E68"/>
                 </a:solidFill>
                 <a:latin typeface="Calibri"/>
               </a:rPr>
-              <a:t>Simulacros de arbitraje en vivo mediante salas de trabajo colaborativo.</a:t>
+              <a:t>•  Arbitrar una ronda simulada aplicando todo lo visto en el curso.</a:t>
+            </a:r>
+          </a:p>
+          <a:p>
+            <a:pPr>
+              <a:spcAft>
+                <a:spcPts val="800"/>
+              </a:spcAft>
+            </a:pPr>
+            <a:r>
+              <a:rPr sz="1800">
+                <a:solidFill>
+                  <a:srgbClr val="334E68"/>
+                </a:solidFill>
+                <a:latin typeface="Calibri"/>
+              </a:rPr>
+              <a:t>•  Observar a otra persona con la lista de cotejo y dar retroalimentación útil.</a:t>
+            </a:r>
+          </a:p>
+          <a:p>
+            <a:pPr>
+              <a:spcAft>
+                <a:spcPts val="800"/>
+              </a:spcAft>
+            </a:pPr>
+            <a:r>
+              <a:rPr sz="1800">
+                <a:solidFill>
+                  <a:srgbClr val="334E68"/>
+                </a:solidFill>
+                <a:latin typeface="Calibri"/>
+              </a:rPr>
+              <a:t>•  Conocer los formularios que se usarán en la sesión presencial.</a:t>
+            </a:r>
+          </a:p>
+          <a:p>
+            <a:pPr>
+              <a:spcAft>
+                <a:spcPts val="800"/>
+              </a:spcAft>
+            </a:pPr>
+            <a:r>
+              <a:rPr sz="1800">
+                <a:solidFill>
+                  <a:srgbClr val="334E68"/>
+                </a:solidFill>
+                <a:latin typeface="Calibri"/>
+              </a:rPr>
+              <a:t>•  Confirmar los roles y los materiales para el torneo real.</a:t>
             </a:r>
           </a:p>
         </p:txBody>
@@ -3808,7 +6123,7 @@
                 </a:solidFill>
                 <a:latin typeface="Calibri"/>
               </a:rPr>
-              <a:t>⚖</a:t>
+              <a:t>◷</a:t>
             </a:r>
           </a:p>
         </p:txBody>
@@ -3822,7 +6137,7 @@
         <p:spPr>
           <a:xfrm>
             <a:off x="1234440" y="530352"/>
-            <a:ext cx="7315200" cy="457200"/>
+            <a:ext cx="9144000" cy="457200"/>
           </a:xfrm>
           <a:prstGeom prst="rect">
             <a:avLst/>
@@ -3842,123 +6157,753 @@
                 </a:solidFill>
                 <a:latin typeface="Calibri"/>
               </a:rPr>
-              <a:t>CONTENIDO DE LA SESIÓN</a:t>
-            </a:r>
-          </a:p>
-        </p:txBody>
-      </p:sp>
-      <p:sp>
-        <p:nvSpPr>
-          <p:cNvPr id="5" name="TextBox 4"/>
-          <p:cNvSpPr txBox="1"/>
-          <p:nvPr/>
-        </p:nvSpPr>
-        <p:spPr>
-          <a:xfrm>
-            <a:off x="548640" y="1051560"/>
-            <a:ext cx="11064240" cy="822960"/>
-          </a:xfrm>
-          <a:prstGeom prst="rect">
-            <a:avLst/>
-          </a:prstGeom>
-          <a:noFill/>
-        </p:spPr>
-        <p:txBody>
-          <a:bodyPr wrap="square">
-            <a:spAutoFit/>
-          </a:bodyPr>
-          <a:lstStyle/>
-          <a:p>
-            <a:r>
-              <a:rPr sz="2400" b="1">
-                <a:solidFill>
-                  <a:srgbClr val="0A1F33"/>
-                </a:solidFill>
-                <a:latin typeface="Cambria"/>
-              </a:rPr>
-              <a:t>Talleres prácticos y simulacros de arbitraje</a:t>
-            </a:r>
-          </a:p>
-        </p:txBody>
-      </p:sp>
-      <p:sp>
-        <p:nvSpPr>
-          <p:cNvPr id="6" name="Rectangle 5"/>
-          <p:cNvSpPr/>
-          <p:nvPr/>
-        </p:nvSpPr>
-        <p:spPr>
-          <a:xfrm>
-            <a:off x="548640" y="1965960"/>
-            <a:ext cx="11064240" cy="4297680"/>
-          </a:xfrm>
-          <a:prstGeom prst="rect">
-            <a:avLst/>
-          </a:prstGeom>
-          <a:solidFill>
-            <a:srgbClr val="F0F4F8"/>
-          </a:solidFill>
-          <a:ln>
-            <a:noFill/>
-          </a:ln>
-          <a:effectLst/>
-        </p:spPr>
-        <p:style>
-          <a:lnRef idx="1">
-            <a:schemeClr val="accent1"/>
-          </a:lnRef>
-          <a:fillRef idx="3">
-            <a:schemeClr val="accent1"/>
-          </a:fillRef>
-          <a:effectRef idx="2">
-            <a:schemeClr val="accent1"/>
-          </a:effectRef>
-          <a:fontRef idx="minor">
-            <a:schemeClr val="lt1"/>
-          </a:fontRef>
-        </p:style>
-        <p:txBody>
-          <a:bodyPr rtlCol="0" anchor="ctr"/>
-          <a:lstStyle/>
-          <a:p>
-            <a:pPr algn="ctr"/>
-          </a:p>
-        </p:txBody>
-      </p:sp>
-      <p:sp>
-        <p:nvSpPr>
-          <p:cNvPr id="7" name="TextBox 6"/>
-          <p:cNvSpPr txBox="1"/>
-          <p:nvPr/>
-        </p:nvSpPr>
-        <p:spPr>
-          <a:xfrm>
-            <a:off x="1005840" y="2331720"/>
-            <a:ext cx="10241280" cy="3566160"/>
-          </a:xfrm>
-          <a:prstGeom prst="rect">
-            <a:avLst/>
-          </a:prstGeom>
-          <a:noFill/>
-        </p:spPr>
-        <p:txBody>
-          <a:bodyPr wrap="square">
-            <a:spAutoFit/>
-          </a:bodyPr>
-          <a:lstStyle/>
-          <a:p>
-            <a:r>
-              <a:rPr sz="1600" b="0">
-                <a:solidFill>
-                  <a:srgbClr val="334E68"/>
-                </a:solidFill>
-                <a:latin typeface="Calibri"/>
-              </a:rPr>
-              <a:t>Revisión de los formularios y de la lista de cotejo oficial que se usará en la sesión presencial.</a:t>
-            </a:r>
-          </a:p>
-        </p:txBody>
-      </p:sp>
+              <a:t>CRONOGRAMA DE LA SESIÓN · 5 HORAS</a:t>
+            </a:r>
+          </a:p>
+        </p:txBody>
+      </p:sp>
+      <p:graphicFrame>
+        <p:nvGraphicFramePr>
+          <p:cNvPr id="5" name="Table 4"/>
+          <p:cNvGraphicFramePr>
+            <a:graphicFrameLocks noGrp="1"/>
+          </p:cNvGraphicFramePr>
+          <p:nvPr/>
+        </p:nvGraphicFramePr>
+        <p:xfrm>
+          <a:off x="548640" y="1143000"/>
+          <a:ext cx="11064240" cy="5029200"/>
+        </p:xfrm>
+        <a:graphic>
+          <a:graphicData uri="http://schemas.openxmlformats.org/drawingml/2006/table">
+            <a:tbl>
+              <a:tblPr firstRow="1" bandRow="1">
+                <a:tableStyleId>{5C22544A-7EE6-4342-B048-85BDC9FD1C3A}</a:tableStyleId>
+              </a:tblPr>
+              <a:tblGrid>
+                <a:gridCol w="1737360"/>
+                <a:gridCol w="1188720"/>
+                <a:gridCol w="8138160"/>
+              </a:tblGrid>
+              <a:tr h="457200">
+                <a:tc>
+                  <a:txBody>
+                    <a:bodyPr/>
+                    <a:lstStyle/>
+                    <a:p>
+                      <a:r>
+                        <a:rPr sz="1300" b="1">
+                          <a:solidFill>
+                            <a:srgbClr val="FFFFFF"/>
+                          </a:solidFill>
+                        </a:rPr>
+                        <a:t>Tiempo</a:t>
+                      </a:r>
+                    </a:p>
+                  </a:txBody>
+                  <a:tcPr>
+                    <a:solidFill>
+                      <a:srgbClr val="102A43"/>
+                    </a:solidFill>
+                  </a:tcPr>
+                </a:tc>
+                <a:tc>
+                  <a:txBody>
+                    <a:bodyPr/>
+                    <a:lstStyle/>
+                    <a:p>
+                      <a:r>
+                        <a:rPr sz="1300" b="1">
+                          <a:solidFill>
+                            <a:srgbClr val="FFFFFF"/>
+                          </a:solidFill>
+                        </a:rPr>
+                        <a:t>Duración</a:t>
+                      </a:r>
+                    </a:p>
+                  </a:txBody>
+                  <a:tcPr>
+                    <a:solidFill>
+                      <a:srgbClr val="102A43"/>
+                    </a:solidFill>
+                  </a:tcPr>
+                </a:tc>
+                <a:tc>
+                  <a:txBody>
+                    <a:bodyPr/>
+                    <a:lstStyle/>
+                    <a:p>
+                      <a:r>
+                        <a:rPr sz="1300" b="1">
+                          <a:solidFill>
+                            <a:srgbClr val="FFFFFF"/>
+                          </a:solidFill>
+                        </a:rPr>
+                        <a:t>Actividad</a:t>
+                      </a:r>
+                    </a:p>
+                  </a:txBody>
+                  <a:tcPr>
+                    <a:solidFill>
+                      <a:srgbClr val="102A43"/>
+                    </a:solidFill>
+                  </a:tcPr>
+                </a:tc>
+              </a:tr>
+              <a:tr h="457200">
+                <a:tc>
+                  <a:txBody>
+                    <a:bodyPr/>
+                    <a:lstStyle/>
+                    <a:p>
+                      <a:r>
+                        <a:rPr sz="1200" b="0">
+                          <a:solidFill>
+                            <a:srgbClr val="334E68"/>
+                          </a:solidFill>
+                        </a:rPr>
+                        <a:t>0:00 – 0:15</a:t>
+                      </a:r>
+                    </a:p>
+                  </a:txBody>
+                  <a:tcPr>
+                    <a:solidFill>
+                      <a:srgbClr val="F0F4F8"/>
+                    </a:solidFill>
+                  </a:tcPr>
+                </a:tc>
+                <a:tc>
+                  <a:txBody>
+                    <a:bodyPr/>
+                    <a:lstStyle/>
+                    <a:p>
+                      <a:r>
+                        <a:rPr sz="1200" b="0">
+                          <a:solidFill>
+                            <a:srgbClr val="334E68"/>
+                          </a:solidFill>
+                        </a:rPr>
+                        <a:t>15 min</a:t>
+                      </a:r>
+                    </a:p>
+                  </a:txBody>
+                  <a:tcPr>
+                    <a:solidFill>
+                      <a:srgbClr val="F0F4F8"/>
+                    </a:solidFill>
+                  </a:tcPr>
+                </a:tc>
+                <a:tc>
+                  <a:txBody>
+                    <a:bodyPr/>
+                    <a:lstStyle/>
+                    <a:p>
+                      <a:r>
+                        <a:rPr sz="1200" b="0">
+                          <a:solidFill>
+                            <a:srgbClr val="334E68"/>
+                          </a:solidFill>
+                        </a:rPr>
+                        <a:t>Repaso y revisión de la tarea</a:t>
+                      </a:r>
+                    </a:p>
+                  </a:txBody>
+                  <a:tcPr>
+                    <a:solidFill>
+                      <a:srgbClr val="F0F4F8"/>
+                    </a:solidFill>
+                  </a:tcPr>
+                </a:tc>
+              </a:tr>
+              <a:tr h="457200">
+                <a:tc>
+                  <a:txBody>
+                    <a:bodyPr/>
+                    <a:lstStyle/>
+                    <a:p>
+                      <a:r>
+                        <a:rPr sz="1200" b="0">
+                          <a:solidFill>
+                            <a:srgbClr val="334E68"/>
+                          </a:solidFill>
+                        </a:rPr>
+                        <a:t>0:15 – 0:45</a:t>
+                      </a:r>
+                    </a:p>
+                  </a:txBody>
+                  <a:tcPr>
+                    <a:solidFill>
+                      <a:srgbClr val="FFFFFF"/>
+                    </a:solidFill>
+                  </a:tcPr>
+                </a:tc>
+                <a:tc>
+                  <a:txBody>
+                    <a:bodyPr/>
+                    <a:lstStyle/>
+                    <a:p>
+                      <a:r>
+                        <a:rPr sz="1200" b="0">
+                          <a:solidFill>
+                            <a:srgbClr val="334E68"/>
+                          </a:solidFill>
+                        </a:rPr>
+                        <a:t>30 min</a:t>
+                      </a:r>
+                    </a:p>
+                  </a:txBody>
+                  <a:tcPr>
+                    <a:solidFill>
+                      <a:srgbClr val="FFFFFF"/>
+                    </a:solidFill>
+                  </a:tcPr>
+                </a:tc>
+                <a:tc>
+                  <a:txBody>
+                    <a:bodyPr/>
+                    <a:lstStyle/>
+                    <a:p>
+                      <a:r>
+                        <a:rPr sz="1200" b="0">
+                          <a:solidFill>
+                            <a:srgbClr val="334E68"/>
+                          </a:solidFill>
+                        </a:rPr>
+                        <a:t>Guía del simulacro y roles</a:t>
+                      </a:r>
+                    </a:p>
+                  </a:txBody>
+                  <a:tcPr>
+                    <a:solidFill>
+                      <a:srgbClr val="FFFFFF"/>
+                    </a:solidFill>
+                  </a:tcPr>
+                </a:tc>
+              </a:tr>
+              <a:tr h="457200">
+                <a:tc>
+                  <a:txBody>
+                    <a:bodyPr/>
+                    <a:lstStyle/>
+                    <a:p>
+                      <a:r>
+                        <a:rPr sz="1200" b="0">
+                          <a:solidFill>
+                            <a:srgbClr val="334E68"/>
+                          </a:solidFill>
+                        </a:rPr>
+                        <a:t>0:45 – 1:15</a:t>
+                      </a:r>
+                    </a:p>
+                  </a:txBody>
+                  <a:tcPr>
+                    <a:solidFill>
+                      <a:srgbClr val="F0F4F8"/>
+                    </a:solidFill>
+                  </a:tcPr>
+                </a:tc>
+                <a:tc>
+                  <a:txBody>
+                    <a:bodyPr/>
+                    <a:lstStyle/>
+                    <a:p>
+                      <a:r>
+                        <a:rPr sz="1200" b="0">
+                          <a:solidFill>
+                            <a:srgbClr val="334E68"/>
+                          </a:solidFill>
+                        </a:rPr>
+                        <a:t>30 min</a:t>
+                      </a:r>
+                    </a:p>
+                  </a:txBody>
+                  <a:tcPr>
+                    <a:solidFill>
+                      <a:srgbClr val="F0F4F8"/>
+                    </a:solidFill>
+                  </a:tcPr>
+                </a:tc>
+                <a:tc>
+                  <a:txBody>
+                    <a:bodyPr/>
+                    <a:lstStyle/>
+                    <a:p>
+                      <a:r>
+                        <a:rPr sz="1200" b="0">
+                          <a:solidFill>
+                            <a:srgbClr val="334E68"/>
+                          </a:solidFill>
+                        </a:rPr>
+                        <a:t>La lista de cotejo y los formularios</a:t>
+                      </a:r>
+                    </a:p>
+                  </a:txBody>
+                  <a:tcPr>
+                    <a:solidFill>
+                      <a:srgbClr val="F0F4F8"/>
+                    </a:solidFill>
+                  </a:tcPr>
+                </a:tc>
+              </a:tr>
+              <a:tr h="457200">
+                <a:tc>
+                  <a:txBody>
+                    <a:bodyPr/>
+                    <a:lstStyle/>
+                    <a:p>
+                      <a:r>
+                        <a:rPr sz="1200" b="1">
+                          <a:solidFill>
+                            <a:srgbClr val="DE911D"/>
+                          </a:solidFill>
+                        </a:rPr>
+                        <a:t>1:15 – 1:30</a:t>
+                      </a:r>
+                    </a:p>
+                  </a:txBody>
+                  <a:tcPr>
+                    <a:solidFill>
+                      <a:srgbClr val="FFFFFF"/>
+                    </a:solidFill>
+                  </a:tcPr>
+                </a:tc>
+                <a:tc>
+                  <a:txBody>
+                    <a:bodyPr/>
+                    <a:lstStyle/>
+                    <a:p>
+                      <a:r>
+                        <a:rPr sz="1200" b="1">
+                          <a:solidFill>
+                            <a:srgbClr val="DE911D"/>
+                          </a:solidFill>
+                        </a:rPr>
+                        <a:t>15 min</a:t>
+                      </a:r>
+                    </a:p>
+                  </a:txBody>
+                  <a:tcPr>
+                    <a:solidFill>
+                      <a:srgbClr val="FFFFFF"/>
+                    </a:solidFill>
+                  </a:tcPr>
+                </a:tc>
+                <a:tc>
+                  <a:txBody>
+                    <a:bodyPr/>
+                    <a:lstStyle/>
+                    <a:p>
+                      <a:r>
+                        <a:rPr sz="1200" b="1">
+                          <a:solidFill>
+                            <a:srgbClr val="DE911D"/>
+                          </a:solidFill>
+                        </a:rPr>
+                        <a:t>Receso</a:t>
+                      </a:r>
+                    </a:p>
+                  </a:txBody>
+                  <a:tcPr>
+                    <a:solidFill>
+                      <a:srgbClr val="FFFFFF"/>
+                    </a:solidFill>
+                  </a:tcPr>
+                </a:tc>
+              </a:tr>
+              <a:tr h="457200">
+                <a:tc>
+                  <a:txBody>
+                    <a:bodyPr/>
+                    <a:lstStyle/>
+                    <a:p>
+                      <a:r>
+                        <a:rPr sz="1200" b="0">
+                          <a:solidFill>
+                            <a:srgbClr val="334E68"/>
+                          </a:solidFill>
+                        </a:rPr>
+                        <a:t>1:30 – 2:30</a:t>
+                      </a:r>
+                    </a:p>
+                  </a:txBody>
+                  <a:tcPr>
+                    <a:solidFill>
+                      <a:srgbClr val="F0F4F8"/>
+                    </a:solidFill>
+                  </a:tcPr>
+                </a:tc>
+                <a:tc>
+                  <a:txBody>
+                    <a:bodyPr/>
+                    <a:lstStyle/>
+                    <a:p>
+                      <a:r>
+                        <a:rPr sz="1200" b="0">
+                          <a:solidFill>
+                            <a:srgbClr val="334E68"/>
+                          </a:solidFill>
+                        </a:rPr>
+                        <a:t>60 min</a:t>
+                      </a:r>
+                    </a:p>
+                  </a:txBody>
+                  <a:tcPr>
+                    <a:solidFill>
+                      <a:srgbClr val="F0F4F8"/>
+                    </a:solidFill>
+                  </a:tcPr>
+                </a:tc>
+                <a:tc>
+                  <a:txBody>
+                    <a:bodyPr/>
+                    <a:lstStyle/>
+                    <a:p>
+                      <a:r>
+                        <a:rPr sz="1200" b="0">
+                          <a:solidFill>
+                            <a:srgbClr val="334E68"/>
+                          </a:solidFill>
+                        </a:rPr>
+                        <a:t>Simulacro 1 en salas de trabajo</a:t>
+                      </a:r>
+                    </a:p>
+                  </a:txBody>
+                  <a:tcPr>
+                    <a:solidFill>
+                      <a:srgbClr val="F0F4F8"/>
+                    </a:solidFill>
+                  </a:tcPr>
+                </a:tc>
+              </a:tr>
+              <a:tr h="457200">
+                <a:tc>
+                  <a:txBody>
+                    <a:bodyPr/>
+                    <a:lstStyle/>
+                    <a:p>
+                      <a:r>
+                        <a:rPr sz="1200" b="0">
+                          <a:solidFill>
+                            <a:srgbClr val="334E68"/>
+                          </a:solidFill>
+                        </a:rPr>
+                        <a:t>2:30 – 3:00</a:t>
+                      </a:r>
+                    </a:p>
+                  </a:txBody>
+                  <a:tcPr>
+                    <a:solidFill>
+                      <a:srgbClr val="FFFFFF"/>
+                    </a:solidFill>
+                  </a:tcPr>
+                </a:tc>
+                <a:tc>
+                  <a:txBody>
+                    <a:bodyPr/>
+                    <a:lstStyle/>
+                    <a:p>
+                      <a:r>
+                        <a:rPr sz="1200" b="0">
+                          <a:solidFill>
+                            <a:srgbClr val="334E68"/>
+                          </a:solidFill>
+                        </a:rPr>
+                        <a:t>30 min</a:t>
+                      </a:r>
+                    </a:p>
+                  </a:txBody>
+                  <a:tcPr>
+                    <a:solidFill>
+                      <a:srgbClr val="FFFFFF"/>
+                    </a:solidFill>
+                  </a:tcPr>
+                </a:tc>
+                <a:tc>
+                  <a:txBody>
+                    <a:bodyPr/>
+                    <a:lstStyle/>
+                    <a:p>
+                      <a:r>
+                        <a:rPr sz="1200" b="0">
+                          <a:solidFill>
+                            <a:srgbClr val="334E68"/>
+                          </a:solidFill>
+                        </a:rPr>
+                        <a:t>Retroalimentación del simulacro 1</a:t>
+                      </a:r>
+                    </a:p>
+                  </a:txBody>
+                  <a:tcPr>
+                    <a:solidFill>
+                      <a:srgbClr val="FFFFFF"/>
+                    </a:solidFill>
+                  </a:tcPr>
+                </a:tc>
+              </a:tr>
+              <a:tr h="457200">
+                <a:tc>
+                  <a:txBody>
+                    <a:bodyPr/>
+                    <a:lstStyle/>
+                    <a:p>
+                      <a:r>
+                        <a:rPr sz="1200" b="1">
+                          <a:solidFill>
+                            <a:srgbClr val="DE911D"/>
+                          </a:solidFill>
+                        </a:rPr>
+                        <a:t>3:00 – 3:15</a:t>
+                      </a:r>
+                    </a:p>
+                  </a:txBody>
+                  <a:tcPr>
+                    <a:solidFill>
+                      <a:srgbClr val="F0F4F8"/>
+                    </a:solidFill>
+                  </a:tcPr>
+                </a:tc>
+                <a:tc>
+                  <a:txBody>
+                    <a:bodyPr/>
+                    <a:lstStyle/>
+                    <a:p>
+                      <a:r>
+                        <a:rPr sz="1200" b="1">
+                          <a:solidFill>
+                            <a:srgbClr val="DE911D"/>
+                          </a:solidFill>
+                        </a:rPr>
+                        <a:t>15 min</a:t>
+                      </a:r>
+                    </a:p>
+                  </a:txBody>
+                  <a:tcPr>
+                    <a:solidFill>
+                      <a:srgbClr val="F0F4F8"/>
+                    </a:solidFill>
+                  </a:tcPr>
+                </a:tc>
+                <a:tc>
+                  <a:txBody>
+                    <a:bodyPr/>
+                    <a:lstStyle/>
+                    <a:p>
+                      <a:r>
+                        <a:rPr sz="1200" b="1">
+                          <a:solidFill>
+                            <a:srgbClr val="DE911D"/>
+                          </a:solidFill>
+                        </a:rPr>
+                        <a:t>Receso</a:t>
+                      </a:r>
+                    </a:p>
+                  </a:txBody>
+                  <a:tcPr>
+                    <a:solidFill>
+                      <a:srgbClr val="F0F4F8"/>
+                    </a:solidFill>
+                  </a:tcPr>
+                </a:tc>
+              </a:tr>
+              <a:tr h="457200">
+                <a:tc>
+                  <a:txBody>
+                    <a:bodyPr/>
+                    <a:lstStyle/>
+                    <a:p>
+                      <a:r>
+                        <a:rPr sz="1200" b="0">
+                          <a:solidFill>
+                            <a:srgbClr val="334E68"/>
+                          </a:solidFill>
+                        </a:rPr>
+                        <a:t>3:15 – 4:15</a:t>
+                      </a:r>
+                    </a:p>
+                  </a:txBody>
+                  <a:tcPr>
+                    <a:solidFill>
+                      <a:srgbClr val="FFFFFF"/>
+                    </a:solidFill>
+                  </a:tcPr>
+                </a:tc>
+                <a:tc>
+                  <a:txBody>
+                    <a:bodyPr/>
+                    <a:lstStyle/>
+                    <a:p>
+                      <a:r>
+                        <a:rPr sz="1200" b="0">
+                          <a:solidFill>
+                            <a:srgbClr val="334E68"/>
+                          </a:solidFill>
+                        </a:rPr>
+                        <a:t>60 min</a:t>
+                      </a:r>
+                    </a:p>
+                  </a:txBody>
+                  <a:tcPr>
+                    <a:solidFill>
+                      <a:srgbClr val="FFFFFF"/>
+                    </a:solidFill>
+                  </a:tcPr>
+                </a:tc>
+                <a:tc>
+                  <a:txBody>
+                    <a:bodyPr/>
+                    <a:lstStyle/>
+                    <a:p>
+                      <a:r>
+                        <a:rPr sz="1200" b="0">
+                          <a:solidFill>
+                            <a:srgbClr val="334E68"/>
+                          </a:solidFill>
+                        </a:rPr>
+                        <a:t>Simulacro 2 con rotación de roles</a:t>
+                      </a:r>
+                    </a:p>
+                  </a:txBody>
+                  <a:tcPr>
+                    <a:solidFill>
+                      <a:srgbClr val="FFFFFF"/>
+                    </a:solidFill>
+                  </a:tcPr>
+                </a:tc>
+              </a:tr>
+              <a:tr h="457200">
+                <a:tc>
+                  <a:txBody>
+                    <a:bodyPr/>
+                    <a:lstStyle/>
+                    <a:p>
+                      <a:r>
+                        <a:rPr sz="1200" b="0">
+                          <a:solidFill>
+                            <a:srgbClr val="334E68"/>
+                          </a:solidFill>
+                        </a:rPr>
+                        <a:t>4:15 – 4:40</a:t>
+                      </a:r>
+                    </a:p>
+                  </a:txBody>
+                  <a:tcPr>
+                    <a:solidFill>
+                      <a:srgbClr val="F0F4F8"/>
+                    </a:solidFill>
+                  </a:tcPr>
+                </a:tc>
+                <a:tc>
+                  <a:txBody>
+                    <a:bodyPr/>
+                    <a:lstStyle/>
+                    <a:p>
+                      <a:r>
+                        <a:rPr sz="1200" b="0">
+                          <a:solidFill>
+                            <a:srgbClr val="334E68"/>
+                          </a:solidFill>
+                        </a:rPr>
+                        <a:t>25 min</a:t>
+                      </a:r>
+                    </a:p>
+                  </a:txBody>
+                  <a:tcPr>
+                    <a:solidFill>
+                      <a:srgbClr val="F0F4F8"/>
+                    </a:solidFill>
+                  </a:tcPr>
+                </a:tc>
+                <a:tc>
+                  <a:txBody>
+                    <a:bodyPr/>
+                    <a:lstStyle/>
+                    <a:p>
+                      <a:r>
+                        <a:rPr sz="1200" b="0">
+                          <a:solidFill>
+                            <a:srgbClr val="334E68"/>
+                          </a:solidFill>
+                        </a:rPr>
+                        <a:t>Asignación de roles para la sesión presencial</a:t>
+                      </a:r>
+                    </a:p>
+                  </a:txBody>
+                  <a:tcPr>
+                    <a:solidFill>
+                      <a:srgbClr val="F0F4F8"/>
+                    </a:solidFill>
+                  </a:tcPr>
+                </a:tc>
+              </a:tr>
+              <a:tr h="457200">
+                <a:tc>
+                  <a:txBody>
+                    <a:bodyPr/>
+                    <a:lstStyle/>
+                    <a:p>
+                      <a:r>
+                        <a:rPr sz="1200" b="0">
+                          <a:solidFill>
+                            <a:srgbClr val="334E68"/>
+                          </a:solidFill>
+                        </a:rPr>
+                        <a:t>4:40 – 5:00</a:t>
+                      </a:r>
+                    </a:p>
+                  </a:txBody>
+                  <a:tcPr>
+                    <a:solidFill>
+                      <a:srgbClr val="FFFFFF"/>
+                    </a:solidFill>
+                  </a:tcPr>
+                </a:tc>
+                <a:tc>
+                  <a:txBody>
+                    <a:bodyPr/>
+                    <a:lstStyle/>
+                    <a:p>
+                      <a:r>
+                        <a:rPr sz="1200" b="0">
+                          <a:solidFill>
+                            <a:srgbClr val="334E68"/>
+                          </a:solidFill>
+                        </a:rPr>
+                        <a:t>20 min</a:t>
+                      </a:r>
+                    </a:p>
+                  </a:txBody>
+                  <a:tcPr>
+                    <a:solidFill>
+                      <a:srgbClr val="FFFFFF"/>
+                    </a:solidFill>
+                  </a:tcPr>
+                </a:tc>
+                <a:tc>
+                  <a:txBody>
+                    <a:bodyPr/>
+                    <a:lstStyle/>
+                    <a:p>
+                      <a:r>
+                        <a:rPr sz="1200" b="0">
+                          <a:solidFill>
+                            <a:srgbClr val="334E68"/>
+                          </a:solidFill>
+                        </a:rPr>
+                        <a:t>Cierre</a:t>
+                      </a:r>
+                    </a:p>
+                  </a:txBody>
+                  <a:tcPr>
+                    <a:solidFill>
+                      <a:srgbClr val="FFFFFF"/>
+                    </a:solidFill>
+                  </a:tcPr>
+                </a:tc>
+              </a:tr>
+            </a:tbl>
+          </a:graphicData>
+        </a:graphic>
+      </p:graphicFrame>
     </p:spTree>
   </p:cSld>
   <p:clrMapOvr>
@@ -4065,7 +7010,7 @@
         <p:spPr>
           <a:xfrm>
             <a:off x="1234440" y="530352"/>
-            <a:ext cx="7315200" cy="457200"/>
+            <a:ext cx="9144000" cy="457200"/>
           </a:xfrm>
           <a:prstGeom prst="rect">
             <a:avLst/>
@@ -4085,7 +7030,7 @@
                 </a:solidFill>
                 <a:latin typeface="Calibri"/>
               </a:rPr>
-              <a:t>CONTENIDO DE LA SESIÓN</a:t>
+              <a:t>CONTENIDO PARA VER EN CLASE</a:t>
             </a:r>
           </a:p>
         </p:txBody>
@@ -4113,13 +7058,13 @@
           <a:lstStyle/>
           <a:p>
             <a:r>
-              <a:rPr sz="2400" b="1">
+              <a:rPr sz="2600" b="1">
                 <a:solidFill>
                   <a:srgbClr val="0A1F33"/>
                 </a:solidFill>
                 <a:latin typeface="Cambria"/>
               </a:rPr>
-              <a:t>Talleres prácticos y simulacros de arbitraje</a:t>
+              <a:t>Cómo funciona el simulacro</a:t>
             </a:r>
           </a:p>
         </p:txBody>
@@ -4132,8 +7077,8 @@
         </p:nvSpPr>
         <p:spPr>
           <a:xfrm>
-            <a:off x="548640" y="1965960"/>
-            <a:ext cx="11064240" cy="4297680"/>
+            <a:off x="548640" y="1874519"/>
+            <a:ext cx="11064240" cy="4389120"/>
           </a:xfrm>
           <a:prstGeom prst="rect">
             <a:avLst/>
@@ -4176,8 +7121,8 @@
         </p:nvSpPr>
         <p:spPr>
           <a:xfrm>
-            <a:off x="1005840" y="2331720"/>
-            <a:ext cx="10241280" cy="3566160"/>
+            <a:off x="914400" y="2011680"/>
+            <a:ext cx="10332720" cy="1371600"/>
           </a:xfrm>
           <a:prstGeom prst="rect">
             <a:avLst/>
@@ -4191,13 +7136,134 @@
           <a:lstStyle/>
           <a:p>
             <a:r>
-              <a:rPr sz="1600" b="0">
+              <a:rPr sz="1500" b="0">
+                <a:solidFill>
+                  <a:srgbClr val="0A1F33"/>
+                </a:solidFill>
+                <a:latin typeface="Calibri"/>
+              </a:rPr>
+              <a:t>En cada sala de trabajo hay tres roles: la persona árbitra, dos personas que representan a los jugadores y actúan una incidencia de la guía, y una persona observadora con la lista de cotejo. La persona árbitra no conoce la incidencia de antemano.</a:t>
+            </a:r>
+          </a:p>
+        </p:txBody>
+      </p:sp>
+      <p:sp>
+        <p:nvSpPr>
+          <p:cNvPr id="8" name="TextBox 7"/>
+          <p:cNvSpPr txBox="1"/>
+          <p:nvPr/>
+        </p:nvSpPr>
+        <p:spPr>
+          <a:xfrm>
+            <a:off x="914400" y="3429000"/>
+            <a:ext cx="10332720" cy="2743200"/>
+          </a:xfrm>
+          <a:prstGeom prst="rect">
+            <a:avLst/>
+          </a:prstGeom>
+          <a:noFill/>
+        </p:spPr>
+        <p:txBody>
+          <a:bodyPr wrap="square">
+            <a:spAutoFit/>
+          </a:bodyPr>
+          <a:lstStyle/>
+          <a:p>
+            <a:pPr>
+              <a:spcAft>
+                <a:spcPts val="800"/>
+              </a:spcAft>
+            </a:pPr>
+            <a:r>
+              <a:rPr sz="1500">
                 <a:solidFill>
                   <a:srgbClr val="334E68"/>
                 </a:solidFill>
                 <a:latin typeface="Calibri"/>
               </a:rPr>
-              <a:t>Asignación de roles para el torneo presencial (árbitro principal, árbitro auxiliar, mesa de control).</a:t>
+              <a:t>•  La incidencia se actúa con un tablero y un reloj reales o con un simulador en pantalla.</a:t>
+            </a:r>
+          </a:p>
+          <a:p>
+            <a:pPr>
+              <a:spcAft>
+                <a:spcPts val="800"/>
+              </a:spcAft>
+            </a:pPr>
+            <a:r>
+              <a:rPr sz="1500">
+                <a:solidFill>
+                  <a:srgbClr val="334E68"/>
+                </a:solidFill>
+                <a:latin typeface="Calibri"/>
+              </a:rPr>
+              <a:t>•  La persona árbitra aplica el método de cuatro pasos y comunica su decisión en voz alta.</a:t>
+            </a:r>
+          </a:p>
+          <a:p>
+            <a:pPr>
+              <a:spcAft>
+                <a:spcPts val="800"/>
+              </a:spcAft>
+            </a:pPr>
+            <a:r>
+              <a:rPr sz="1500">
+                <a:solidFill>
+                  <a:srgbClr val="334E68"/>
+                </a:solidFill>
+                <a:latin typeface="Calibri"/>
+              </a:rPr>
+              <a:t>•  La persona observadora marca Sí o No en cada ítem y anota observaciones concretas.</a:t>
+            </a:r>
+          </a:p>
+          <a:p>
+            <a:pPr>
+              <a:spcAft>
+                <a:spcPts val="800"/>
+              </a:spcAft>
+            </a:pPr>
+            <a:r>
+              <a:rPr sz="1500">
+                <a:solidFill>
+                  <a:srgbClr val="334E68"/>
+                </a:solidFill>
+                <a:latin typeface="Calibri"/>
+              </a:rPr>
+              <a:t>•  Al final de cada incidencia se rotan los roles.</a:t>
+            </a:r>
+          </a:p>
+        </p:txBody>
+      </p:sp>
+      <p:sp>
+        <p:nvSpPr>
+          <p:cNvPr id="9" name="TextBox 8"/>
+          <p:cNvSpPr txBox="1"/>
+          <p:nvPr/>
+        </p:nvSpPr>
+        <p:spPr>
+          <a:xfrm>
+            <a:off x="548640" y="6355080"/>
+            <a:ext cx="11064240" cy="365760"/>
+          </a:xfrm>
+          <a:prstGeom prst="rect">
+            <a:avLst/>
+          </a:prstGeom>
+          <a:noFill/>
+        </p:spPr>
+        <p:txBody>
+          <a:bodyPr wrap="square">
+            <a:spAutoFit/>
+          </a:bodyPr>
+          <a:lstStyle/>
+          <a:p>
+            <a:r>
+              <a:rPr sz="1100" b="0">
+                <a:solidFill>
+                  <a:srgbClr val="627D98"/>
+                </a:solidFill>
+                <a:latin typeface="Calibri"/>
+              </a:rPr>
+              <a:t>Fuente: Metodología del curso</a:t>
             </a:r>
           </a:p>
         </p:txBody>
@@ -4222,6 +7288,1009 @@
       <p:grpSpPr/>
       <p:sp>
         <p:nvSpPr>
+          <p:cNvPr id="2" name="Oval 1"/>
+          <p:cNvSpPr/>
+          <p:nvPr/>
+        </p:nvSpPr>
+        <p:spPr>
+          <a:xfrm>
+            <a:off x="548640" y="502920"/>
+            <a:ext cx="502920" cy="502920"/>
+          </a:xfrm>
+          <a:prstGeom prst="ellipse">
+            <a:avLst/>
+          </a:prstGeom>
+          <a:solidFill>
+            <a:srgbClr val="DE911D"/>
+          </a:solidFill>
+          <a:ln>
+            <a:noFill/>
+          </a:ln>
+          <a:effectLst/>
+        </p:spPr>
+        <p:style>
+          <a:lnRef idx="1">
+            <a:schemeClr val="accent1"/>
+          </a:lnRef>
+          <a:fillRef idx="3">
+            <a:schemeClr val="accent1"/>
+          </a:fillRef>
+          <a:effectRef idx="2">
+            <a:schemeClr val="accent1"/>
+          </a:effectRef>
+          <a:fontRef idx="minor">
+            <a:schemeClr val="lt1"/>
+          </a:fontRef>
+        </p:style>
+        <p:txBody>
+          <a:bodyPr rtlCol="0" anchor="ctr"/>
+          <a:lstStyle/>
+          <a:p>
+            <a:pPr algn="ctr"/>
+          </a:p>
+        </p:txBody>
+      </p:sp>
+      <p:sp>
+        <p:nvSpPr>
+          <p:cNvPr id="3" name="TextBox 2"/>
+          <p:cNvSpPr txBox="1"/>
+          <p:nvPr/>
+        </p:nvSpPr>
+        <p:spPr>
+          <a:xfrm>
+            <a:off x="548640" y="502920"/>
+            <a:ext cx="502920" cy="502920"/>
+          </a:xfrm>
+          <a:prstGeom prst="rect">
+            <a:avLst/>
+          </a:prstGeom>
+          <a:noFill/>
+        </p:spPr>
+        <p:txBody>
+          <a:bodyPr wrap="square">
+            <a:spAutoFit/>
+          </a:bodyPr>
+          <a:lstStyle/>
+          <a:p>
+            <a:pPr algn="ctr"/>
+            <a:r>
+              <a:rPr sz="2000" b="0">
+                <a:solidFill>
+                  <a:srgbClr val="0A1F33"/>
+                </a:solidFill>
+                <a:latin typeface="Calibri"/>
+              </a:rPr>
+              <a:t>⚖</a:t>
+            </a:r>
+          </a:p>
+        </p:txBody>
+      </p:sp>
+      <p:sp>
+        <p:nvSpPr>
+          <p:cNvPr id="4" name="TextBox 3"/>
+          <p:cNvSpPr txBox="1"/>
+          <p:nvPr/>
+        </p:nvSpPr>
+        <p:spPr>
+          <a:xfrm>
+            <a:off x="1234440" y="530352"/>
+            <a:ext cx="9144000" cy="457200"/>
+          </a:xfrm>
+          <a:prstGeom prst="rect">
+            <a:avLst/>
+          </a:prstGeom>
+          <a:noFill/>
+        </p:spPr>
+        <p:txBody>
+          <a:bodyPr wrap="square">
+            <a:spAutoFit/>
+          </a:bodyPr>
+          <a:lstStyle/>
+          <a:p>
+            <a:r>
+              <a:rPr sz="1400" b="1">
+                <a:solidFill>
+                  <a:srgbClr val="DE911D"/>
+                </a:solidFill>
+                <a:latin typeface="Calibri"/>
+              </a:rPr>
+              <a:t>CONTENIDO PARA VER EN CLASE</a:t>
+            </a:r>
+          </a:p>
+        </p:txBody>
+      </p:sp>
+      <p:sp>
+        <p:nvSpPr>
+          <p:cNvPr id="5" name="TextBox 4"/>
+          <p:cNvSpPr txBox="1"/>
+          <p:nvPr/>
+        </p:nvSpPr>
+        <p:spPr>
+          <a:xfrm>
+            <a:off x="548640" y="1051560"/>
+            <a:ext cx="11064240" cy="822960"/>
+          </a:xfrm>
+          <a:prstGeom prst="rect">
+            <a:avLst/>
+          </a:prstGeom>
+          <a:noFill/>
+        </p:spPr>
+        <p:txBody>
+          <a:bodyPr wrap="square">
+            <a:spAutoFit/>
+          </a:bodyPr>
+          <a:lstStyle/>
+          <a:p>
+            <a:r>
+              <a:rPr sz="2600" b="1">
+                <a:solidFill>
+                  <a:srgbClr val="0A1F33"/>
+                </a:solidFill>
+                <a:latin typeface="Cambria"/>
+              </a:rPr>
+              <a:t>La lista de cotejo de desempeño arbitral</a:t>
+            </a:r>
+          </a:p>
+        </p:txBody>
+      </p:sp>
+      <p:sp>
+        <p:nvSpPr>
+          <p:cNvPr id="6" name="Rectangle 5"/>
+          <p:cNvSpPr/>
+          <p:nvPr/>
+        </p:nvSpPr>
+        <p:spPr>
+          <a:xfrm>
+            <a:off x="548640" y="1874519"/>
+            <a:ext cx="11064240" cy="4389120"/>
+          </a:xfrm>
+          <a:prstGeom prst="rect">
+            <a:avLst/>
+          </a:prstGeom>
+          <a:solidFill>
+            <a:srgbClr val="F0F4F8"/>
+          </a:solidFill>
+          <a:ln>
+            <a:noFill/>
+          </a:ln>
+          <a:effectLst/>
+        </p:spPr>
+        <p:style>
+          <a:lnRef idx="1">
+            <a:schemeClr val="accent1"/>
+          </a:lnRef>
+          <a:fillRef idx="3">
+            <a:schemeClr val="accent1"/>
+          </a:fillRef>
+          <a:effectRef idx="2">
+            <a:schemeClr val="accent1"/>
+          </a:effectRef>
+          <a:fontRef idx="minor">
+            <a:schemeClr val="lt1"/>
+          </a:fontRef>
+        </p:style>
+        <p:txBody>
+          <a:bodyPr rtlCol="0" anchor="ctr"/>
+          <a:lstStyle/>
+          <a:p>
+            <a:pPr algn="ctr"/>
+          </a:p>
+        </p:txBody>
+      </p:sp>
+      <p:sp>
+        <p:nvSpPr>
+          <p:cNvPr id="7" name="TextBox 6"/>
+          <p:cNvSpPr txBox="1"/>
+          <p:nvPr/>
+        </p:nvSpPr>
+        <p:spPr>
+          <a:xfrm>
+            <a:off x="914400" y="2011680"/>
+            <a:ext cx="10332720" cy="1371600"/>
+          </a:xfrm>
+          <a:prstGeom prst="rect">
+            <a:avLst/>
+          </a:prstGeom>
+          <a:noFill/>
+        </p:spPr>
+        <p:txBody>
+          <a:bodyPr wrap="square">
+            <a:spAutoFit/>
+          </a:bodyPr>
+          <a:lstStyle/>
+          <a:p>
+            <a:r>
+              <a:rPr sz="1500" b="0">
+                <a:solidFill>
+                  <a:srgbClr val="0A1F33"/>
+                </a:solidFill>
+                <a:latin typeface="Calibri"/>
+              </a:rPr>
+              <a:t>La lista de cotejo es el instrumento con el que se evalúa el desempeño en el torneo real de la sesión presencial. Conocerla de antemano permite prepararse para cada ítem.</a:t>
+            </a:r>
+          </a:p>
+        </p:txBody>
+      </p:sp>
+      <p:sp>
+        <p:nvSpPr>
+          <p:cNvPr id="8" name="TextBox 7"/>
+          <p:cNvSpPr txBox="1"/>
+          <p:nvPr/>
+        </p:nvSpPr>
+        <p:spPr>
+          <a:xfrm>
+            <a:off x="914400" y="3429000"/>
+            <a:ext cx="10332720" cy="2743200"/>
+          </a:xfrm>
+          <a:prstGeom prst="rect">
+            <a:avLst/>
+          </a:prstGeom>
+          <a:noFill/>
+        </p:spPr>
+        <p:txBody>
+          <a:bodyPr wrap="square">
+            <a:spAutoFit/>
+          </a:bodyPr>
+          <a:lstStyle/>
+          <a:p>
+            <a:pPr>
+              <a:spcAft>
+                <a:spcPts val="800"/>
+              </a:spcAft>
+            </a:pPr>
+            <a:r>
+              <a:rPr sz="1300">
+                <a:solidFill>
+                  <a:srgbClr val="334E68"/>
+                </a:solidFill>
+                <a:latin typeface="Calibri"/>
+              </a:rPr>
+              <a:t>•  Verifica la acreditación y el emparejamiento antes de iniciar la ronda.</a:t>
+            </a:r>
+          </a:p>
+          <a:p>
+            <a:pPr>
+              <a:spcAft>
+                <a:spcPts val="800"/>
+              </a:spcAft>
+            </a:pPr>
+            <a:r>
+              <a:rPr sz="1300">
+                <a:solidFill>
+                  <a:srgbClr val="334E68"/>
+                </a:solidFill>
+                <a:latin typeface="Calibri"/>
+              </a:rPr>
+              <a:t>•  Aplica correctamente las reglas básicas y resuelve reclamos con el procedimiento del reglamento.</a:t>
+            </a:r>
+          </a:p>
+          <a:p>
+            <a:pPr>
+              <a:spcAft>
+                <a:spcPts val="800"/>
+              </a:spcAft>
+            </a:pPr>
+            <a:r>
+              <a:rPr sz="1300">
+                <a:solidFill>
+                  <a:srgbClr val="334E68"/>
+                </a:solidFill>
+                <a:latin typeface="Calibri"/>
+              </a:rPr>
+              <a:t>•  Gestiona con criterio las incidencias con el reloj.</a:t>
+            </a:r>
+          </a:p>
+          <a:p>
+            <a:pPr>
+              <a:spcAft>
+                <a:spcPts val="800"/>
+              </a:spcAft>
+            </a:pPr>
+            <a:r>
+              <a:rPr sz="1300">
+                <a:solidFill>
+                  <a:srgbClr val="334E68"/>
+                </a:solidFill>
+                <a:latin typeface="Calibri"/>
+              </a:rPr>
+              <a:t>•  Aplica las sanciones correspondientes ante faltas o dispositivos no autorizados.</a:t>
+            </a:r>
+          </a:p>
+          <a:p>
+            <a:pPr>
+              <a:spcAft>
+                <a:spcPts val="800"/>
+              </a:spcAft>
+            </a:pPr>
+            <a:r>
+              <a:rPr sz="1300">
+                <a:solidFill>
+                  <a:srgbClr val="334E68"/>
+                </a:solidFill>
+                <a:latin typeface="Calibri"/>
+              </a:rPr>
+              <a:t>•  Calcula correctamente los desempates.</a:t>
+            </a:r>
+          </a:p>
+          <a:p>
+            <a:pPr>
+              <a:spcAft>
+                <a:spcPts val="800"/>
+              </a:spcAft>
+            </a:pPr>
+            <a:r>
+              <a:rPr sz="1300">
+                <a:solidFill>
+                  <a:srgbClr val="334E68"/>
+                </a:solidFill>
+                <a:latin typeface="Calibri"/>
+              </a:rPr>
+              <a:t>•  Mantiene un trato respetuoso e imparcial y documenta cada incidencia.</a:t>
+            </a:r>
+          </a:p>
+        </p:txBody>
+      </p:sp>
+      <p:sp>
+        <p:nvSpPr>
+          <p:cNvPr id="9" name="TextBox 8"/>
+          <p:cNvSpPr txBox="1"/>
+          <p:nvPr/>
+        </p:nvSpPr>
+        <p:spPr>
+          <a:xfrm>
+            <a:off x="548640" y="6355080"/>
+            <a:ext cx="11064240" cy="365760"/>
+          </a:xfrm>
+          <a:prstGeom prst="rect">
+            <a:avLst/>
+          </a:prstGeom>
+          <a:noFill/>
+        </p:spPr>
+        <p:txBody>
+          <a:bodyPr wrap="square">
+            <a:spAutoFit/>
+          </a:bodyPr>
+          <a:lstStyle/>
+          <a:p>
+            <a:r>
+              <a:rPr sz="1100" b="0">
+                <a:solidFill>
+                  <a:srgbClr val="627D98"/>
+                </a:solidFill>
+                <a:latin typeface="Calibri"/>
+              </a:rPr>
+              <a:t>Fuente: Lista de cotejo oficial del curso (formularios de la Sesión 8)</a:t>
+            </a:r>
+          </a:p>
+        </p:txBody>
+      </p:sp>
+    </p:spTree>
+  </p:cSld>
+  <p:clrMapOvr>
+    <a:masterClrMapping/>
+  </p:clrMapOvr>
+</p:sld>
+</file>
+
+<file path=ppt/slides/slide6.xml><?xml version="1.0" encoding="utf-8"?>
+<p:sld xmlns:a="http://schemas.openxmlformats.org/drawingml/2006/main" xmlns:p="http://schemas.openxmlformats.org/presentationml/2006/main" xmlns:r="http://schemas.openxmlformats.org/officeDocument/2006/relationships">
+  <p:cSld>
+    <p:spTree>
+      <p:nvGrpSpPr>
+        <p:cNvPr id="1" name=""/>
+        <p:cNvGrpSpPr/>
+        <p:nvPr/>
+      </p:nvGrpSpPr>
+      <p:grpSpPr/>
+      <p:sp>
+        <p:nvSpPr>
+          <p:cNvPr id="2" name="Oval 1"/>
+          <p:cNvSpPr/>
+          <p:nvPr/>
+        </p:nvSpPr>
+        <p:spPr>
+          <a:xfrm>
+            <a:off x="548640" y="502920"/>
+            <a:ext cx="502920" cy="502920"/>
+          </a:xfrm>
+          <a:prstGeom prst="ellipse">
+            <a:avLst/>
+          </a:prstGeom>
+          <a:solidFill>
+            <a:srgbClr val="DE911D"/>
+          </a:solidFill>
+          <a:ln>
+            <a:noFill/>
+          </a:ln>
+          <a:effectLst/>
+        </p:spPr>
+        <p:style>
+          <a:lnRef idx="1">
+            <a:schemeClr val="accent1"/>
+          </a:lnRef>
+          <a:fillRef idx="3">
+            <a:schemeClr val="accent1"/>
+          </a:fillRef>
+          <a:effectRef idx="2">
+            <a:schemeClr val="accent1"/>
+          </a:effectRef>
+          <a:fontRef idx="minor">
+            <a:schemeClr val="lt1"/>
+          </a:fontRef>
+        </p:style>
+        <p:txBody>
+          <a:bodyPr rtlCol="0" anchor="ctr"/>
+          <a:lstStyle/>
+          <a:p>
+            <a:pPr algn="ctr"/>
+          </a:p>
+        </p:txBody>
+      </p:sp>
+      <p:sp>
+        <p:nvSpPr>
+          <p:cNvPr id="3" name="TextBox 2"/>
+          <p:cNvSpPr txBox="1"/>
+          <p:nvPr/>
+        </p:nvSpPr>
+        <p:spPr>
+          <a:xfrm>
+            <a:off x="548640" y="502920"/>
+            <a:ext cx="502920" cy="502920"/>
+          </a:xfrm>
+          <a:prstGeom prst="rect">
+            <a:avLst/>
+          </a:prstGeom>
+          <a:noFill/>
+        </p:spPr>
+        <p:txBody>
+          <a:bodyPr wrap="square">
+            <a:spAutoFit/>
+          </a:bodyPr>
+          <a:lstStyle/>
+          <a:p>
+            <a:pPr algn="ctr"/>
+            <a:r>
+              <a:rPr sz="2000" b="0">
+                <a:solidFill>
+                  <a:srgbClr val="0A1F33"/>
+                </a:solidFill>
+                <a:latin typeface="Calibri"/>
+              </a:rPr>
+              <a:t>⚖</a:t>
+            </a:r>
+          </a:p>
+        </p:txBody>
+      </p:sp>
+      <p:sp>
+        <p:nvSpPr>
+          <p:cNvPr id="4" name="TextBox 3"/>
+          <p:cNvSpPr txBox="1"/>
+          <p:nvPr/>
+        </p:nvSpPr>
+        <p:spPr>
+          <a:xfrm>
+            <a:off x="1234440" y="530352"/>
+            <a:ext cx="9144000" cy="457200"/>
+          </a:xfrm>
+          <a:prstGeom prst="rect">
+            <a:avLst/>
+          </a:prstGeom>
+          <a:noFill/>
+        </p:spPr>
+        <p:txBody>
+          <a:bodyPr wrap="square">
+            <a:spAutoFit/>
+          </a:bodyPr>
+          <a:lstStyle/>
+          <a:p>
+            <a:r>
+              <a:rPr sz="1400" b="1">
+                <a:solidFill>
+                  <a:srgbClr val="DE911D"/>
+                </a:solidFill>
+                <a:latin typeface="Calibri"/>
+              </a:rPr>
+              <a:t>CONTENIDO PARA VER EN CLASE</a:t>
+            </a:r>
+          </a:p>
+        </p:txBody>
+      </p:sp>
+      <p:sp>
+        <p:nvSpPr>
+          <p:cNvPr id="5" name="TextBox 4"/>
+          <p:cNvSpPr txBox="1"/>
+          <p:nvPr/>
+        </p:nvSpPr>
+        <p:spPr>
+          <a:xfrm>
+            <a:off x="548640" y="1051560"/>
+            <a:ext cx="11064240" cy="822960"/>
+          </a:xfrm>
+          <a:prstGeom prst="rect">
+            <a:avLst/>
+          </a:prstGeom>
+          <a:noFill/>
+        </p:spPr>
+        <p:txBody>
+          <a:bodyPr wrap="square">
+            <a:spAutoFit/>
+          </a:bodyPr>
+          <a:lstStyle/>
+          <a:p>
+            <a:r>
+              <a:rPr sz="2600" b="1">
+                <a:solidFill>
+                  <a:srgbClr val="0A1F33"/>
+                </a:solidFill>
+                <a:latin typeface="Cambria"/>
+              </a:rPr>
+              <a:t>Roles en el torneo presencial</a:t>
+            </a:r>
+          </a:p>
+        </p:txBody>
+      </p:sp>
+      <p:sp>
+        <p:nvSpPr>
+          <p:cNvPr id="6" name="Rectangle 5"/>
+          <p:cNvSpPr/>
+          <p:nvPr/>
+        </p:nvSpPr>
+        <p:spPr>
+          <a:xfrm>
+            <a:off x="548640" y="1874519"/>
+            <a:ext cx="11064240" cy="4389120"/>
+          </a:xfrm>
+          <a:prstGeom prst="rect">
+            <a:avLst/>
+          </a:prstGeom>
+          <a:solidFill>
+            <a:srgbClr val="F0F4F8"/>
+          </a:solidFill>
+          <a:ln>
+            <a:noFill/>
+          </a:ln>
+          <a:effectLst/>
+        </p:spPr>
+        <p:style>
+          <a:lnRef idx="1">
+            <a:schemeClr val="accent1"/>
+          </a:lnRef>
+          <a:fillRef idx="3">
+            <a:schemeClr val="accent1"/>
+          </a:fillRef>
+          <a:effectRef idx="2">
+            <a:schemeClr val="accent1"/>
+          </a:effectRef>
+          <a:fontRef idx="minor">
+            <a:schemeClr val="lt1"/>
+          </a:fontRef>
+        </p:style>
+        <p:txBody>
+          <a:bodyPr rtlCol="0" anchor="ctr"/>
+          <a:lstStyle/>
+          <a:p>
+            <a:pPr algn="ctr"/>
+          </a:p>
+        </p:txBody>
+      </p:sp>
+      <p:sp>
+        <p:nvSpPr>
+          <p:cNvPr id="7" name="TextBox 6"/>
+          <p:cNvSpPr txBox="1"/>
+          <p:nvPr/>
+        </p:nvSpPr>
+        <p:spPr>
+          <a:xfrm>
+            <a:off x="914400" y="2011680"/>
+            <a:ext cx="10332720" cy="1371600"/>
+          </a:xfrm>
+          <a:prstGeom prst="rect">
+            <a:avLst/>
+          </a:prstGeom>
+          <a:noFill/>
+        </p:spPr>
+        <p:txBody>
+          <a:bodyPr wrap="square">
+            <a:spAutoFit/>
+          </a:bodyPr>
+          <a:lstStyle/>
+          <a:p>
+            <a:r>
+              <a:rPr sz="1500" b="0">
+                <a:solidFill>
+                  <a:srgbClr val="0A1F33"/>
+                </a:solidFill>
+                <a:latin typeface="Calibri"/>
+              </a:rPr>
+              <a:t>En la sesión presencial se organiza y arbitra un torneo real. Cada participante tiene un rol asignado y rota durante las rondas.</a:t>
+            </a:r>
+          </a:p>
+        </p:txBody>
+      </p:sp>
+      <p:sp>
+        <p:nvSpPr>
+          <p:cNvPr id="8" name="TextBox 7"/>
+          <p:cNvSpPr txBox="1"/>
+          <p:nvPr/>
+        </p:nvSpPr>
+        <p:spPr>
+          <a:xfrm>
+            <a:off x="914400" y="3429000"/>
+            <a:ext cx="10332720" cy="2743200"/>
+          </a:xfrm>
+          <a:prstGeom prst="rect">
+            <a:avLst/>
+          </a:prstGeom>
+          <a:noFill/>
+        </p:spPr>
+        <p:txBody>
+          <a:bodyPr wrap="square">
+            <a:spAutoFit/>
+          </a:bodyPr>
+          <a:lstStyle/>
+          <a:p>
+            <a:pPr>
+              <a:spcAft>
+                <a:spcPts val="800"/>
+              </a:spcAft>
+            </a:pPr>
+            <a:r>
+              <a:rPr sz="1500">
+                <a:solidFill>
+                  <a:srgbClr val="334E68"/>
+                </a:solidFill>
+                <a:latin typeface="Calibri"/>
+              </a:rPr>
+              <a:t>•  Árbitro principal: decide las incidencias y coordina al equipo.</a:t>
+            </a:r>
+          </a:p>
+          <a:p>
+            <a:pPr>
+              <a:spcAft>
+                <a:spcPts val="800"/>
+              </a:spcAft>
+            </a:pPr>
+            <a:r>
+              <a:rPr sz="1500">
+                <a:solidFill>
+                  <a:srgbClr val="334E68"/>
+                </a:solidFill>
+                <a:latin typeface="Calibri"/>
+              </a:rPr>
+              <a:t>•  Árbitros auxiliares: supervisan un grupo de mesas, informan y aplican lo acordado.</a:t>
+            </a:r>
+          </a:p>
+          <a:p>
+            <a:pPr>
+              <a:spcAft>
+                <a:spcPts val="800"/>
+              </a:spcAft>
+            </a:pPr>
+            <a:r>
+              <a:rPr sz="1500">
+                <a:solidFill>
+                  <a:srgbClr val="334E68"/>
+                </a:solidFill>
+                <a:latin typeface="Calibri"/>
+              </a:rPr>
+              <a:t>•  Mesa de control: inscripción, emparejamientos, resultados y desempates.</a:t>
+            </a:r>
+          </a:p>
+          <a:p>
+            <a:pPr>
+              <a:spcAft>
+                <a:spcPts val="800"/>
+              </a:spcAft>
+            </a:pPr>
+            <a:r>
+              <a:rPr sz="1500">
+                <a:solidFill>
+                  <a:srgbClr val="334E68"/>
+                </a:solidFill>
+                <a:latin typeface="Calibri"/>
+              </a:rPr>
+              <a:t>•  Todas las personas completan la lista de cotejo de otra en al menos una ronda.</a:t>
+            </a:r>
+          </a:p>
+        </p:txBody>
+      </p:sp>
+      <p:sp>
+        <p:nvSpPr>
+          <p:cNvPr id="9" name="TextBox 8"/>
+          <p:cNvSpPr txBox="1"/>
+          <p:nvPr/>
+        </p:nvSpPr>
+        <p:spPr>
+          <a:xfrm>
+            <a:off x="548640" y="6355080"/>
+            <a:ext cx="11064240" cy="365760"/>
+          </a:xfrm>
+          <a:prstGeom prst="rect">
+            <a:avLst/>
+          </a:prstGeom>
+          <a:noFill/>
+        </p:spPr>
+        <p:txBody>
+          <a:bodyPr wrap="square">
+            <a:spAutoFit/>
+          </a:bodyPr>
+          <a:lstStyle/>
+          <a:p>
+            <a:r>
+              <a:rPr sz="1100" b="0">
+                <a:solidFill>
+                  <a:srgbClr val="627D98"/>
+                </a:solidFill>
+                <a:latin typeface="Calibri"/>
+              </a:rPr>
+              <a:t>Fuente: Leyes del Ajedrez 2023 (Handbook E.I.01), art. 12.4; Manual del árbitro de la FIDE</a:t>
+            </a:r>
+          </a:p>
+        </p:txBody>
+      </p:sp>
+    </p:spTree>
+  </p:cSld>
+  <p:clrMapOvr>
+    <a:masterClrMapping/>
+  </p:clrMapOvr>
+</p:sld>
+</file>
+
+<file path=ppt/slides/slide7.xml><?xml version="1.0" encoding="utf-8"?>
+<p:sld xmlns:a="http://schemas.openxmlformats.org/drawingml/2006/main" xmlns:p="http://schemas.openxmlformats.org/presentationml/2006/main" xmlns:r="http://schemas.openxmlformats.org/officeDocument/2006/relationships">
+  <p:cSld>
+    <p:spTree>
+      <p:nvGrpSpPr>
+        <p:cNvPr id="1" name=""/>
+        <p:cNvGrpSpPr/>
+        <p:nvPr/>
+      </p:nvGrpSpPr>
+      <p:grpSpPr/>
+      <p:sp>
+        <p:nvSpPr>
+          <p:cNvPr id="2" name="Oval 1"/>
+          <p:cNvSpPr/>
+          <p:nvPr/>
+        </p:nvSpPr>
+        <p:spPr>
+          <a:xfrm>
+            <a:off x="548640" y="502920"/>
+            <a:ext cx="502920" cy="502920"/>
+          </a:xfrm>
+          <a:prstGeom prst="ellipse">
+            <a:avLst/>
+          </a:prstGeom>
+          <a:solidFill>
+            <a:srgbClr val="DE911D"/>
+          </a:solidFill>
+          <a:ln>
+            <a:noFill/>
+          </a:ln>
+          <a:effectLst/>
+        </p:spPr>
+        <p:style>
+          <a:lnRef idx="1">
+            <a:schemeClr val="accent1"/>
+          </a:lnRef>
+          <a:fillRef idx="3">
+            <a:schemeClr val="accent1"/>
+          </a:fillRef>
+          <a:effectRef idx="2">
+            <a:schemeClr val="accent1"/>
+          </a:effectRef>
+          <a:fontRef idx="minor">
+            <a:schemeClr val="lt1"/>
+          </a:fontRef>
+        </p:style>
+        <p:txBody>
+          <a:bodyPr rtlCol="0" anchor="ctr"/>
+          <a:lstStyle/>
+          <a:p>
+            <a:pPr algn="ctr"/>
+          </a:p>
+        </p:txBody>
+      </p:sp>
+      <p:sp>
+        <p:nvSpPr>
+          <p:cNvPr id="3" name="TextBox 2"/>
+          <p:cNvSpPr txBox="1"/>
+          <p:nvPr/>
+        </p:nvSpPr>
+        <p:spPr>
+          <a:xfrm>
+            <a:off x="548640" y="502920"/>
+            <a:ext cx="502920" cy="502920"/>
+          </a:xfrm>
+          <a:prstGeom prst="rect">
+            <a:avLst/>
+          </a:prstGeom>
+          <a:noFill/>
+        </p:spPr>
+        <p:txBody>
+          <a:bodyPr wrap="square">
+            <a:spAutoFit/>
+          </a:bodyPr>
+          <a:lstStyle/>
+          <a:p>
+            <a:pPr algn="ctr"/>
+            <a:r>
+              <a:rPr sz="2000" b="0">
+                <a:solidFill>
+                  <a:srgbClr val="0A1F33"/>
+                </a:solidFill>
+                <a:latin typeface="Calibri"/>
+              </a:rPr>
+              <a:t>?</a:t>
+            </a:r>
+          </a:p>
+        </p:txBody>
+      </p:sp>
+      <p:sp>
+        <p:nvSpPr>
+          <p:cNvPr id="4" name="TextBox 3"/>
+          <p:cNvSpPr txBox="1"/>
+          <p:nvPr/>
+        </p:nvSpPr>
+        <p:spPr>
+          <a:xfrm>
+            <a:off x="1234440" y="530352"/>
+            <a:ext cx="9144000" cy="457200"/>
+          </a:xfrm>
+          <a:prstGeom prst="rect">
+            <a:avLst/>
+          </a:prstGeom>
+          <a:noFill/>
+        </p:spPr>
+        <p:txBody>
+          <a:bodyPr wrap="square">
+            <a:spAutoFit/>
+          </a:bodyPr>
+          <a:lstStyle/>
+          <a:p>
+            <a:r>
+              <a:rPr sz="1400" b="1">
+                <a:solidFill>
+                  <a:srgbClr val="DE911D"/>
+                </a:solidFill>
+                <a:latin typeface="Calibri"/>
+              </a:rPr>
+              <a:t>CASO 1 · ¿QUÉ DECIDE LA PERSONA ÁRBITRA?</a:t>
+            </a:r>
+          </a:p>
+        </p:txBody>
+      </p:sp>
+      <p:sp>
+        <p:nvSpPr>
+          <p:cNvPr id="5" name="TextBox 4"/>
+          <p:cNvSpPr txBox="1"/>
+          <p:nvPr/>
+        </p:nvSpPr>
+        <p:spPr>
+          <a:xfrm>
+            <a:off x="548640" y="1051560"/>
+            <a:ext cx="11064240" cy="822960"/>
+          </a:xfrm>
+          <a:prstGeom prst="rect">
+            <a:avLst/>
+          </a:prstGeom>
+          <a:noFill/>
+        </p:spPr>
+        <p:txBody>
+          <a:bodyPr wrap="square">
+            <a:spAutoFit/>
+          </a:bodyPr>
+          <a:lstStyle/>
+          <a:p>
+            <a:r>
+              <a:rPr sz="2600" b="1">
+                <a:solidFill>
+                  <a:srgbClr val="0A1F33"/>
+                </a:solidFill>
+                <a:latin typeface="Cambria"/>
+              </a:rPr>
+              <a:t>Guion A: el enroque dudoso</a:t>
+            </a:r>
+          </a:p>
+        </p:txBody>
+      </p:sp>
+      <p:sp>
+        <p:nvSpPr>
+          <p:cNvPr id="6" name="Rectangle 5"/>
+          <p:cNvSpPr/>
+          <p:nvPr/>
+        </p:nvSpPr>
+        <p:spPr>
+          <a:xfrm>
+            <a:off x="548640" y="1965960"/>
+            <a:ext cx="11064240" cy="4206240"/>
+          </a:xfrm>
+          <a:prstGeom prst="rect">
+            <a:avLst/>
+          </a:prstGeom>
+          <a:solidFill>
+            <a:srgbClr val="F0F4F8"/>
+          </a:solidFill>
+          <a:ln>
+            <a:noFill/>
+          </a:ln>
+          <a:effectLst/>
+        </p:spPr>
+        <p:style>
+          <a:lnRef idx="1">
+            <a:schemeClr val="accent1"/>
+          </a:lnRef>
+          <a:fillRef idx="3">
+            <a:schemeClr val="accent1"/>
+          </a:fillRef>
+          <a:effectRef idx="2">
+            <a:schemeClr val="accent1"/>
+          </a:effectRef>
+          <a:fontRef idx="minor">
+            <a:schemeClr val="lt1"/>
+          </a:fontRef>
+        </p:style>
+        <p:txBody>
+          <a:bodyPr rtlCol="0" anchor="ctr"/>
+          <a:lstStyle/>
+          <a:p>
+            <a:pPr algn="ctr"/>
+          </a:p>
+        </p:txBody>
+      </p:sp>
+      <p:sp>
+        <p:nvSpPr>
+          <p:cNvPr id="7" name="TextBox 6"/>
+          <p:cNvSpPr txBox="1"/>
+          <p:nvPr/>
+        </p:nvSpPr>
+        <p:spPr>
+          <a:xfrm>
+            <a:off x="914400" y="2240280"/>
+            <a:ext cx="10332720" cy="3749039"/>
+          </a:xfrm>
+          <a:prstGeom prst="rect">
+            <a:avLst/>
+          </a:prstGeom>
+          <a:noFill/>
+        </p:spPr>
+        <p:txBody>
+          <a:bodyPr wrap="square">
+            <a:spAutoFit/>
+          </a:bodyPr>
+          <a:lstStyle/>
+          <a:p>
+            <a:r>
+              <a:rPr sz="2000" b="0">
+                <a:solidFill>
+                  <a:srgbClr val="334E68"/>
+                </a:solidFill>
+                <a:latin typeface="Calibri"/>
+              </a:rPr>
+              <a:t>El jugador de negras enroca largo; el de blancas reclama que el rey ya se había movido en la jugada 9 y había vuelto.</a:t>
+            </a:r>
+          </a:p>
+        </p:txBody>
+      </p:sp>
+    </p:spTree>
+  </p:cSld>
+  <p:clrMapOvr>
+    <a:masterClrMapping/>
+  </p:clrMapOvr>
+</p:sld>
+</file>
+
+<file path=ppt/slides/slide8.xml><?xml version="1.0" encoding="utf-8"?>
+<p:sld xmlns:a="http://schemas.openxmlformats.org/drawingml/2006/main" xmlns:p="http://schemas.openxmlformats.org/presentationml/2006/main" xmlns:r="http://schemas.openxmlformats.org/officeDocument/2006/relationships">
+  <p:cSld>
+    <p:spTree>
+      <p:nvGrpSpPr>
+        <p:cNvPr id="1" name=""/>
+        <p:cNvGrpSpPr/>
+        <p:nvPr/>
+      </p:nvGrpSpPr>
+      <p:grpSpPr/>
+      <p:sp>
+        <p:nvSpPr>
           <p:cNvPr id="2" name="Rectangle 1"/>
           <p:cNvSpPr/>
           <p:nvPr/>
@@ -4266,58 +8335,168 @@
       </p:sp>
       <p:sp>
         <p:nvSpPr>
-          <p:cNvPr id="3" name="Oval 2"/>
+          <p:cNvPr id="3" name="TextBox 2"/>
+          <p:cNvSpPr txBox="1"/>
+          <p:nvPr/>
+        </p:nvSpPr>
+        <p:spPr>
+          <a:xfrm>
+            <a:off x="548640" y="548640"/>
+            <a:ext cx="11064240" cy="457200"/>
+          </a:xfrm>
+          <a:prstGeom prst="rect">
+            <a:avLst/>
+          </a:prstGeom>
+          <a:noFill/>
+        </p:spPr>
+        <p:txBody>
+          <a:bodyPr wrap="square">
+            <a:spAutoFit/>
+          </a:bodyPr>
+          <a:lstStyle/>
+          <a:p>
+            <a:r>
+              <a:rPr sz="1400" b="1">
+                <a:solidFill>
+                  <a:srgbClr val="F0B429"/>
+                </a:solidFill>
+                <a:latin typeface="Calibri"/>
+              </a:rPr>
+              <a:t>CASO 1 · DECISIÓN</a:t>
+            </a:r>
+          </a:p>
+        </p:txBody>
+      </p:sp>
+      <p:sp>
+        <p:nvSpPr>
+          <p:cNvPr id="4" name="TextBox 3"/>
+          <p:cNvSpPr txBox="1"/>
+          <p:nvPr/>
+        </p:nvSpPr>
+        <p:spPr>
+          <a:xfrm>
+            <a:off x="548640" y="1051560"/>
+            <a:ext cx="11064240" cy="822960"/>
+          </a:xfrm>
+          <a:prstGeom prst="rect">
+            <a:avLst/>
+          </a:prstGeom>
+          <a:noFill/>
+        </p:spPr>
+        <p:txBody>
+          <a:bodyPr wrap="square">
+            <a:spAutoFit/>
+          </a:bodyPr>
+          <a:lstStyle/>
+          <a:p>
+            <a:r>
+              <a:rPr sz="2600" b="1">
+                <a:solidFill>
+                  <a:srgbClr val="FFFFFF"/>
+                </a:solidFill>
+                <a:latin typeface="Cambria"/>
+              </a:rPr>
+              <a:t>Guion A: el enroque dudoso</a:t>
+            </a:r>
+          </a:p>
+        </p:txBody>
+      </p:sp>
+      <p:sp>
+        <p:nvSpPr>
+          <p:cNvPr id="5" name="TextBox 4"/>
+          <p:cNvSpPr txBox="1"/>
+          <p:nvPr/>
+        </p:nvSpPr>
+        <p:spPr>
+          <a:xfrm>
+            <a:off x="548640" y="2103120"/>
+            <a:ext cx="11064240" cy="3931920"/>
+          </a:xfrm>
+          <a:prstGeom prst="rect">
+            <a:avLst/>
+          </a:prstGeom>
+          <a:noFill/>
+        </p:spPr>
+        <p:txBody>
+          <a:bodyPr wrap="square">
+            <a:spAutoFit/>
+          </a:bodyPr>
+          <a:lstStyle/>
+          <a:p>
+            <a:r>
+              <a:rPr sz="2000" b="0">
+                <a:solidFill>
+                  <a:srgbClr val="CADCFC"/>
+                </a:solidFill>
+                <a:latin typeface="Calibri"/>
+              </a:rPr>
+              <a:t>Se revisan las planillas. Si el rey se movió, el enroque fue una jugada ilegal: se repone la posición, el jugador debe mover el rey (pieza tocada) y el rival recibe la compensación de tiempo que corresponde al ritmo.</a:t>
+            </a:r>
+          </a:p>
+        </p:txBody>
+      </p:sp>
+      <p:sp>
+        <p:nvSpPr>
+          <p:cNvPr id="6" name="TextBox 5"/>
+          <p:cNvSpPr txBox="1"/>
+          <p:nvPr/>
+        </p:nvSpPr>
+        <p:spPr>
+          <a:xfrm>
+            <a:off x="548640" y="6263640"/>
+            <a:ext cx="11064240" cy="365760"/>
+          </a:xfrm>
+          <a:prstGeom prst="rect">
+            <a:avLst/>
+          </a:prstGeom>
+          <a:noFill/>
+        </p:spPr>
+        <p:txBody>
+          <a:bodyPr wrap="square">
+            <a:spAutoFit/>
+          </a:bodyPr>
+          <a:lstStyle/>
+          <a:p>
+            <a:r>
+              <a:rPr sz="1100" b="0">
+                <a:solidFill>
+                  <a:srgbClr val="9FB3C8"/>
+                </a:solidFill>
+                <a:latin typeface="Calibri"/>
+              </a:rPr>
+              <a:t>Fuente: Leyes del Ajedrez 2023 (Handbook E.I.01), art. 3.8.2.1, 4.3 y 7.5</a:t>
+            </a:r>
+          </a:p>
+        </p:txBody>
+      </p:sp>
+    </p:spTree>
+  </p:cSld>
+  <p:clrMapOvr>
+    <a:masterClrMapping/>
+  </p:clrMapOvr>
+</p:sld>
+</file>
+
+<file path=ppt/slides/slide9.xml><?xml version="1.0" encoding="utf-8"?>
+<p:sld xmlns:a="http://schemas.openxmlformats.org/drawingml/2006/main" xmlns:p="http://schemas.openxmlformats.org/presentationml/2006/main" xmlns:r="http://schemas.openxmlformats.org/officeDocument/2006/relationships">
+  <p:cSld>
+    <p:spTree>
+      <p:nvGrpSpPr>
+        <p:cNvPr id="1" name=""/>
+        <p:cNvGrpSpPr/>
+        <p:nvPr/>
+      </p:nvGrpSpPr>
+      <p:grpSpPr/>
+      <p:sp>
+        <p:nvSpPr>
+          <p:cNvPr id="2" name="Oval 1"/>
           <p:cNvSpPr/>
           <p:nvPr/>
         </p:nvSpPr>
         <p:spPr>
           <a:xfrm>
-            <a:off x="-1280160" y="-1463040"/>
-            <a:ext cx="4114800" cy="4114800"/>
-          </a:xfrm>
-          <a:prstGeom prst="ellipse">
-            <a:avLst/>
-          </a:prstGeom>
-          <a:solidFill>
-            <a:srgbClr val="0A1F33"/>
-          </a:solidFill>
-          <a:ln>
-            <a:noFill/>
-          </a:ln>
-          <a:effectLst/>
-        </p:spPr>
-        <p:style>
-          <a:lnRef idx="1">
-            <a:schemeClr val="accent1"/>
-          </a:lnRef>
-          <a:fillRef idx="3">
-            <a:schemeClr val="accent1"/>
-          </a:fillRef>
-          <a:effectRef idx="2">
-            <a:schemeClr val="accent1"/>
-          </a:effectRef>
-          <a:fontRef idx="minor">
-            <a:schemeClr val="lt1"/>
-          </a:fontRef>
-        </p:style>
-        <p:txBody>
-          <a:bodyPr rtlCol="0" anchor="ctr"/>
-          <a:lstStyle/>
-          <a:p>
-            <a:pPr algn="ctr"/>
-          </a:p>
-        </p:txBody>
-      </p:sp>
-      <p:sp>
-        <p:nvSpPr>
-          <p:cNvPr id="4" name="Oval 3"/>
-          <p:cNvSpPr/>
-          <p:nvPr/>
-        </p:nvSpPr>
-        <p:spPr>
-          <a:xfrm>
-            <a:off x="5175504" y="822960"/>
-            <a:ext cx="1828800" cy="1828800"/>
+            <a:off x="548640" y="502920"/>
+            <a:ext cx="502920" cy="502920"/>
           </a:xfrm>
           <a:prstGeom prst="ellipse">
             <a:avLst/>
@@ -4354,14 +8533,14 @@
       </p:sp>
       <p:sp>
         <p:nvSpPr>
-          <p:cNvPr id="5" name="TextBox 4"/>
+          <p:cNvPr id="3" name="TextBox 2"/>
           <p:cNvSpPr txBox="1"/>
           <p:nvPr/>
         </p:nvSpPr>
         <p:spPr>
           <a:xfrm>
-            <a:off x="5175504" y="822960"/>
-            <a:ext cx="1828800" cy="1828800"/>
+            <a:off x="548640" y="502920"/>
+            <a:ext cx="502920" cy="502920"/>
           </a:xfrm>
           <a:prstGeom prst="rect">
             <a:avLst/>
@@ -4376,27 +8555,27 @@
           <a:p>
             <a:pPr algn="ctr"/>
             <a:r>
-              <a:rPr sz="4400" b="1">
+              <a:rPr sz="2000" b="0">
                 <a:solidFill>
                   <a:srgbClr val="0A1F33"/>
                 </a:solidFill>
                 <a:latin typeface="Calibri"/>
               </a:rPr>
-              <a:t>✔</a:t>
-            </a:r>
-          </a:p>
-        </p:txBody>
-      </p:sp>
-      <p:sp>
-        <p:nvSpPr>
-          <p:cNvPr id="6" name="TextBox 5"/>
+              <a:t>?</a:t>
+            </a:r>
+          </a:p>
+        </p:txBody>
+      </p:sp>
+      <p:sp>
+        <p:nvSpPr>
+          <p:cNvPr id="4" name="TextBox 3"/>
           <p:cNvSpPr txBox="1"/>
           <p:nvPr/>
         </p:nvSpPr>
         <p:spPr>
           <a:xfrm>
-            <a:off x="548640" y="2880360"/>
-            <a:ext cx="11064240" cy="457200"/>
+            <a:off x="1234440" y="530352"/>
+            <a:ext cx="9144000" cy="457200"/>
           </a:xfrm>
           <a:prstGeom prst="rect">
             <a:avLst/>
@@ -4409,29 +8588,28 @@
           </a:bodyPr>
           <a:lstStyle/>
           <a:p>
-            <a:pPr algn="ctr"/>
             <a:r>
               <a:rPr sz="1400" b="1">
                 <a:solidFill>
-                  <a:srgbClr val="F0B429"/>
+                  <a:srgbClr val="DE911D"/>
                 </a:solidFill>
                 <a:latin typeface="Calibri"/>
               </a:rPr>
-              <a:t>PRÁCTICA — SIMULACRO DE ARBITRAJE CON OBSERVACIÓN ENTRE PARES</a:t>
-            </a:r>
-          </a:p>
-        </p:txBody>
-      </p:sp>
-      <p:sp>
-        <p:nvSpPr>
-          <p:cNvPr id="7" name="TextBox 6"/>
+              <a:t>CASO 2 · ¿QUÉ DECIDE LA PERSONA ÁRBITRA?</a:t>
+            </a:r>
+          </a:p>
+        </p:txBody>
+      </p:sp>
+      <p:sp>
+        <p:nvSpPr>
+          <p:cNvPr id="5" name="TextBox 4"/>
           <p:cNvSpPr txBox="1"/>
           <p:nvPr/>
         </p:nvSpPr>
         <p:spPr>
           <a:xfrm>
-            <a:off x="1280160" y="3383280"/>
-            <a:ext cx="9601200" cy="2377440"/>
+            <a:off x="548640" y="1051560"/>
+            <a:ext cx="11064240" cy="822960"/>
           </a:xfrm>
           <a:prstGeom prst="rect">
             <a:avLst/>
@@ -4444,29 +8622,72 @@
           </a:bodyPr>
           <a:lstStyle/>
           <a:p>
+            <a:r>
+              <a:rPr sz="2600" b="1">
+                <a:solidFill>
+                  <a:srgbClr val="0A1F33"/>
+                </a:solidFill>
+                <a:latin typeface="Cambria"/>
+              </a:rPr>
+              <a:t>Guion B: reclamo de triple repetición</a:t>
+            </a:r>
+          </a:p>
+        </p:txBody>
+      </p:sp>
+      <p:sp>
+        <p:nvSpPr>
+          <p:cNvPr id="6" name="Rectangle 5"/>
+          <p:cNvSpPr/>
+          <p:nvPr/>
+        </p:nvSpPr>
+        <p:spPr>
+          <a:xfrm>
+            <a:off x="548640" y="1965960"/>
+            <a:ext cx="11064240" cy="4206240"/>
+          </a:xfrm>
+          <a:prstGeom prst="rect">
+            <a:avLst/>
+          </a:prstGeom>
+          <a:solidFill>
+            <a:srgbClr val="F0F4F8"/>
+          </a:solidFill>
+          <a:ln>
+            <a:noFill/>
+          </a:ln>
+          <a:effectLst/>
+        </p:spPr>
+        <p:style>
+          <a:lnRef idx="1">
+            <a:schemeClr val="accent1"/>
+          </a:lnRef>
+          <a:fillRef idx="3">
+            <a:schemeClr val="accent1"/>
+          </a:fillRef>
+          <a:effectRef idx="2">
+            <a:schemeClr val="accent1"/>
+          </a:effectRef>
+          <a:fontRef idx="minor">
+            <a:schemeClr val="lt1"/>
+          </a:fontRef>
+        </p:style>
+        <p:txBody>
+          <a:bodyPr rtlCol="0" anchor="ctr"/>
+          <a:lstStyle/>
+          <a:p>
             <a:pPr algn="ctr"/>
-            <a:r>
-              <a:rPr sz="2000" b="0">
-                <a:solidFill>
-                  <a:srgbClr val="FFFFFF"/>
-                </a:solidFill>
-                <a:latin typeface="Cambria"/>
-              </a:rPr>
-              <a:t>Cada participante arbitra una partida simulada mientras otra persona observa y completa la lista de cotejo; luego se intercambian los roles.</a:t>
-            </a:r>
-          </a:p>
-        </p:txBody>
-      </p:sp>
-      <p:sp>
-        <p:nvSpPr>
-          <p:cNvPr id="8" name="TextBox 7"/>
+          </a:p>
+        </p:txBody>
+      </p:sp>
+      <p:sp>
+        <p:nvSpPr>
+          <p:cNvPr id="7" name="TextBox 6"/>
           <p:cNvSpPr txBox="1"/>
           <p:nvPr/>
         </p:nvSpPr>
         <p:spPr>
           <a:xfrm>
-            <a:off x="548640" y="6263640"/>
-            <a:ext cx="11064240" cy="365760"/>
+            <a:off x="914400" y="2240280"/>
+            <a:ext cx="10332720" cy="3749039"/>
           </a:xfrm>
           <a:prstGeom prst="rect">
             <a:avLst/>
@@ -4479,15 +8700,14 @@
           </a:bodyPr>
           <a:lstStyle/>
           <a:p>
-            <a:pPr algn="ctr"/>
-            <a:r>
-              <a:rPr sz="1200" b="0">
-                <a:solidFill>
-                  <a:srgbClr val="9FB3C8"/>
+            <a:r>
+              <a:rPr sz="2000" b="0">
+                <a:solidFill>
+                  <a:srgbClr val="334E68"/>
                 </a:solidFill>
                 <a:latin typeface="Calibri"/>
               </a:rPr>
-              <a:t>Formación Ajedrez · Sesión 7</a:t>
+              <a:t>Un jugador detiene el reloj y dice que la posición se repitió tres veces. Todavía no hizo la jugada que produciría la tercera repetición.</a:t>
             </a:r>
           </a:p>
         </p:txBody>

</xml_diff>